<commit_message>
add a misc card
</commit_message>
<xml_diff>
--- a/topic03-dataTypes-variables-and-expressions/unit-1/talk-1/a-data-types.pptx
+++ b/topic03-dataTypes-variables-and-expressions/unit-1/talk-1/a-data-types.pptx
@@ -5,10 +5,10 @@
     <p:sldMasterId id="2147483955" r:id="rId1"/>
   </p:sldMasterIdLst>
   <p:notesMasterIdLst>
-    <p:notesMasterId r:id="rId31"/>
+    <p:notesMasterId r:id="rId33"/>
   </p:notesMasterIdLst>
   <p:handoutMasterIdLst>
-    <p:handoutMasterId r:id="rId32"/>
+    <p:handoutMasterId r:id="rId34"/>
   </p:handoutMasterIdLst>
   <p:sldIdLst>
     <p:sldId id="256" r:id="rId2"/>
@@ -36,10 +36,12 @@
     <p:sldId id="278" r:id="rId24"/>
     <p:sldId id="368" r:id="rId25"/>
     <p:sldId id="369" r:id="rId26"/>
-    <p:sldId id="371" r:id="rId27"/>
-    <p:sldId id="307" r:id="rId28"/>
-    <p:sldId id="372" r:id="rId29"/>
-    <p:sldId id="347" r:id="rId30"/>
+    <p:sldId id="373" r:id="rId27"/>
+    <p:sldId id="279" r:id="rId28"/>
+    <p:sldId id="371" r:id="rId29"/>
+    <p:sldId id="307" r:id="rId30"/>
+    <p:sldId id="372" r:id="rId31"/>
+    <p:sldId id="347" r:id="rId32"/>
   </p:sldIdLst>
   <p:sldSz cx="12192000" cy="6858000"/>
   <p:notesSz cx="6858000" cy="9144000"/>
@@ -509,14 +511,14 @@
           </a:ln>
           <a:extLst>
             <a:ext uri="{909E8E84-426E-40dd-AFC4-6F175D3DCCD1}">
-              <a14:hiddenFill xmlns:a14="http://schemas.microsoft.com/office/drawing/2010/main" xmlns="">
+              <a14:hiddenFill xmlns="" xmlns:a14="http://schemas.microsoft.com/office/drawing/2010/main">
                 <a:solidFill>
                   <a:srgbClr val="FFFFFF"/>
                 </a:solidFill>
               </a14:hiddenFill>
             </a:ext>
             <a:ext uri="{FAA26D3D-D897-4be2-8F04-BA451C77F1D7}">
-              <ma14:placeholderFlag xmlns:ma14="http://schemas.microsoft.com/office/mac/drawingml/2011/main" xmlns="" val="1"/>
+              <ma14:placeholderFlag xmlns="" xmlns:ma14="http://schemas.microsoft.com/office/mac/drawingml/2011/main" val="1"/>
             </a:ext>
           </a:extLst>
         </p:spPr>
@@ -860,14 +862,14 @@
           <a:noFill/>
           <a:extLst>
             <a:ext uri="{909E8E84-426E-40dd-AFC4-6F175D3DCCD1}">
-              <a14:hiddenFill xmlns:a14="http://schemas.microsoft.com/office/drawing/2010/main" xmlns="">
+              <a14:hiddenFill xmlns="" xmlns:a14="http://schemas.microsoft.com/office/drawing/2010/main">
                 <a:solidFill>
                   <a:srgbClr val="FFFFFF"/>
                 </a:solidFill>
               </a14:hiddenFill>
             </a:ext>
             <a:ext uri="{91240B29-F687-4f45-9708-019B960494DF}">
-              <a14:hiddenLine xmlns:a14="http://schemas.microsoft.com/office/drawing/2010/main" xmlns="" w="9525">
+              <a14:hiddenLine xmlns="" xmlns:a14="http://schemas.microsoft.com/office/drawing/2010/main" w="9525">
                 <a:solidFill>
                   <a:srgbClr val="000000"/>
                 </a:solidFill>
@@ -1015,14 +1017,14 @@
           <a:noFill/>
           <a:extLst>
             <a:ext uri="{909E8E84-426E-40dd-AFC4-6F175D3DCCD1}">
-              <a14:hiddenFill xmlns:a14="http://schemas.microsoft.com/office/drawing/2010/main" xmlns="">
+              <a14:hiddenFill xmlns="" xmlns:a14="http://schemas.microsoft.com/office/drawing/2010/main">
                 <a:solidFill>
                   <a:srgbClr val="FFFFFF"/>
                 </a:solidFill>
               </a14:hiddenFill>
             </a:ext>
             <a:ext uri="{91240B29-F687-4f45-9708-019B960494DF}">
-              <a14:hiddenLine xmlns:a14="http://schemas.microsoft.com/office/drawing/2010/main" xmlns="" w="9525">
+              <a14:hiddenLine xmlns="" xmlns:a14="http://schemas.microsoft.com/office/drawing/2010/main" w="9525">
                 <a:solidFill>
                   <a:srgbClr val="000000"/>
                 </a:solidFill>
@@ -1170,14 +1172,14 @@
           <a:noFill/>
           <a:extLst>
             <a:ext uri="{909E8E84-426E-40dd-AFC4-6F175D3DCCD1}">
-              <a14:hiddenFill xmlns:a14="http://schemas.microsoft.com/office/drawing/2010/main" xmlns="">
+              <a14:hiddenFill xmlns="" xmlns:a14="http://schemas.microsoft.com/office/drawing/2010/main">
                 <a:solidFill>
                   <a:srgbClr val="FFFFFF"/>
                 </a:solidFill>
               </a14:hiddenFill>
             </a:ext>
             <a:ext uri="{91240B29-F687-4f45-9708-019B960494DF}">
-              <a14:hiddenLine xmlns:a14="http://schemas.microsoft.com/office/drawing/2010/main" xmlns="" w="9525">
+              <a14:hiddenLine xmlns="" xmlns:a14="http://schemas.microsoft.com/office/drawing/2010/main" w="9525">
                 <a:solidFill>
                   <a:srgbClr val="000000"/>
                 </a:solidFill>
@@ -1349,7 +1351,7 @@
         <p:spPr>
           <a:extLst>
             <a:ext uri="{FAA26D3D-D897-4be2-8F04-BA451C77F1D7}">
-              <ma14:placeholderFlag xmlns:ma14="http://schemas.microsoft.com/office/mac/drawingml/2011/main" xmlns="" val="1"/>
+              <ma14:placeholderFlag xmlns="" xmlns:ma14="http://schemas.microsoft.com/office/mac/drawingml/2011/main" val="1"/>
             </a:ext>
           </a:extLst>
         </p:spPr>
@@ -1514,14 +1516,14 @@
           <a:noFill/>
           <a:extLst>
             <a:ext uri="{909E8E84-426E-40dd-AFC4-6F175D3DCCD1}">
-              <a14:hiddenFill xmlns:a14="http://schemas.microsoft.com/office/drawing/2010/main" xmlns="">
+              <a14:hiddenFill xmlns="" xmlns:a14="http://schemas.microsoft.com/office/drawing/2010/main">
                 <a:solidFill>
                   <a:srgbClr val="FFFFFF"/>
                 </a:solidFill>
               </a14:hiddenFill>
             </a:ext>
             <a:ext uri="{91240B29-F687-4f45-9708-019B960494DF}">
-              <a14:hiddenLine xmlns:a14="http://schemas.microsoft.com/office/drawing/2010/main" xmlns="" w="9525">
+              <a14:hiddenLine xmlns="" xmlns:a14="http://schemas.microsoft.com/office/drawing/2010/main" w="9525">
                 <a:solidFill>
                   <a:srgbClr val="000000"/>
                 </a:solidFill>
@@ -1669,14 +1671,14 @@
           <a:noFill/>
           <a:extLst>
             <a:ext uri="{909E8E84-426E-40dd-AFC4-6F175D3DCCD1}">
-              <a14:hiddenFill xmlns:a14="http://schemas.microsoft.com/office/drawing/2010/main" xmlns="">
+              <a14:hiddenFill xmlns="" xmlns:a14="http://schemas.microsoft.com/office/drawing/2010/main">
                 <a:solidFill>
                   <a:srgbClr val="FFFFFF"/>
                 </a:solidFill>
               </a14:hiddenFill>
             </a:ext>
             <a:ext uri="{91240B29-F687-4f45-9708-019B960494DF}">
-              <a14:hiddenLine xmlns:a14="http://schemas.microsoft.com/office/drawing/2010/main" xmlns="" w="9525">
+              <a14:hiddenLine xmlns="" xmlns:a14="http://schemas.microsoft.com/office/drawing/2010/main" w="9525">
                 <a:solidFill>
                   <a:srgbClr val="000000"/>
                 </a:solidFill>
@@ -1824,14 +1826,14 @@
           <a:noFill/>
           <a:extLst>
             <a:ext uri="{909E8E84-426E-40dd-AFC4-6F175D3DCCD1}">
-              <a14:hiddenFill xmlns:a14="http://schemas.microsoft.com/office/drawing/2010/main" xmlns="">
+              <a14:hiddenFill xmlns="" xmlns:a14="http://schemas.microsoft.com/office/drawing/2010/main">
                 <a:solidFill>
                   <a:srgbClr val="FFFFFF"/>
                 </a:solidFill>
               </a14:hiddenFill>
             </a:ext>
             <a:ext uri="{91240B29-F687-4f45-9708-019B960494DF}">
-              <a14:hiddenLine xmlns:a14="http://schemas.microsoft.com/office/drawing/2010/main" xmlns="" w="9525">
+              <a14:hiddenLine xmlns="" xmlns:a14="http://schemas.microsoft.com/office/drawing/2010/main" w="9525">
                 <a:solidFill>
                   <a:srgbClr val="000000"/>
                 </a:solidFill>
@@ -2003,7 +2005,7 @@
         <p:spPr>
           <a:extLst>
             <a:ext uri="{FAA26D3D-D897-4be2-8F04-BA451C77F1D7}">
-              <ma14:placeholderFlag xmlns:ma14="http://schemas.microsoft.com/office/mac/drawingml/2011/main" xmlns="" val="1"/>
+              <ma14:placeholderFlag xmlns="" xmlns:ma14="http://schemas.microsoft.com/office/mac/drawingml/2011/main" val="1"/>
             </a:ext>
           </a:extLst>
         </p:spPr>
@@ -2507,6 +2509,99 @@
     <p:extLst>
       <p:ext uri="{BB962C8B-B14F-4D97-AF65-F5344CB8AC3E}">
         <p14:creationId xmlns:p14="http://schemas.microsoft.com/office/powerpoint/2010/main" val="684736897"/>
+      </p:ext>
+    </p:extLst>
+  </p:cSld>
+  <p:clrMapOvr>
+    <a:masterClrMapping/>
+  </p:clrMapOvr>
+</p:notes>
+</file>
+
+<file path=ppt/notesSlides/notesSlide9.xml><?xml version="1.0" encoding="utf-8"?>
+<p:notes xmlns:a="http://schemas.openxmlformats.org/drawingml/2006/main" xmlns:r="http://schemas.openxmlformats.org/officeDocument/2006/relationships" xmlns:p="http://schemas.openxmlformats.org/presentationml/2006/main">
+  <p:cSld>
+    <p:spTree>
+      <p:nvGrpSpPr>
+        <p:cNvPr id="1" name=""/>
+        <p:cNvGrpSpPr/>
+        <p:nvPr/>
+      </p:nvGrpSpPr>
+      <p:grpSpPr>
+        <a:xfrm>
+          <a:off x="0" y="0"/>
+          <a:ext cx="0" cy="0"/>
+          <a:chOff x="0" y="0"/>
+          <a:chExt cx="0" cy="0"/>
+        </a:xfrm>
+      </p:grpSpPr>
+      <p:sp>
+        <p:nvSpPr>
+          <p:cNvPr id="7" name="Rectangle 7"/>
+          <p:cNvSpPr>
+            <a:spLocks noGrp="1" noChangeArrowheads="1"/>
+          </p:cNvSpPr>
+          <p:nvPr>
+            <p:ph type="sldNum" sz="quarter" idx="5"/>
+          </p:nvPr>
+        </p:nvSpPr>
+        <p:spPr>
+          <a:ln/>
+        </p:spPr>
+        <p:txBody>
+          <a:bodyPr/>
+          <a:lstStyle/>
+          <a:p>
+            <a:fld id="{2DDBB281-C514-8742-9D24-3A3D1BD36245}" type="slidenum">
+              <a:rPr lang="en-US"/>
+              <a:pPr/>
+              <a:t>27</a:t>
+            </a:fld>
+            <a:endParaRPr lang="en-US"/>
+          </a:p>
+        </p:txBody>
+      </p:sp>
+      <p:sp>
+        <p:nvSpPr>
+          <p:cNvPr id="43010" name="Rectangle 2"/>
+          <p:cNvSpPr>
+            <a:spLocks noGrp="1" noRot="1" noChangeAspect="1" noChangeArrowheads="1" noTextEdit="1"/>
+          </p:cNvSpPr>
+          <p:nvPr>
+            <p:ph type="sldImg"/>
+          </p:nvPr>
+        </p:nvSpPr>
+        <p:spPr>
+          <a:xfrm>
+            <a:off x="381000" y="685800"/>
+            <a:ext cx="6096000" cy="3429000"/>
+          </a:xfrm>
+          <a:ln/>
+        </p:spPr>
+      </p:sp>
+      <p:sp>
+        <p:nvSpPr>
+          <p:cNvPr id="43011" name="Rectangle 3"/>
+          <p:cNvSpPr>
+            <a:spLocks noGrp="1" noChangeArrowheads="1"/>
+          </p:cNvSpPr>
+          <p:nvPr>
+            <p:ph type="body" idx="1"/>
+          </p:nvPr>
+        </p:nvSpPr>
+        <p:spPr/>
+        <p:txBody>
+          <a:bodyPr/>
+          <a:lstStyle/>
+          <a:p>
+            <a:endParaRPr lang="en-US"/>
+          </a:p>
+        </p:txBody>
+      </p:sp>
+    </p:spTree>
+    <p:extLst>
+      <p:ext uri="{BB962C8B-B14F-4D97-AF65-F5344CB8AC3E}">
+        <p14:creationId xmlns:p14="http://schemas.microsoft.com/office/powerpoint/2010/main" val="1646701114"/>
       </p:ext>
     </p:extLst>
   </p:cSld>
@@ -2697,7 +2792,7 @@
           <a:p>
             <a:fld id="{C764DE79-268F-4C1A-8933-263129D2AF90}" type="datetimeFigureOut">
               <a:rPr lang="en-US" smtClean="0"/>
-              <a:t>9/28/25</a:t>
+              <a:t>10/1/25</a:t>
             </a:fld>
             <a:endParaRPr lang="en-US" dirty="0"/>
           </a:p>
@@ -2868,7 +2963,7 @@
           <a:p>
             <a:fld id="{C764DE79-268F-4C1A-8933-263129D2AF90}" type="datetimeFigureOut">
               <a:rPr lang="en-US" smtClean="0"/>
-              <a:t>9/28/25</a:t>
+              <a:t>10/1/25</a:t>
             </a:fld>
             <a:endParaRPr lang="en-US" dirty="0"/>
           </a:p>
@@ -3049,7 +3144,7 @@
           <a:p>
             <a:fld id="{C764DE79-268F-4C1A-8933-263129D2AF90}" type="datetimeFigureOut">
               <a:rPr lang="en-US" smtClean="0"/>
-              <a:t>9/28/25</a:t>
+              <a:t>10/1/25</a:t>
             </a:fld>
             <a:endParaRPr lang="en-US" dirty="0"/>
           </a:p>
@@ -3687,7 +3782,7 @@
           <a:p>
             <a:fld id="{C764DE79-268F-4C1A-8933-263129D2AF90}" type="datetimeFigureOut">
               <a:rPr lang="en-US" smtClean="0"/>
-              <a:t>9/28/25</a:t>
+              <a:t>10/1/25</a:t>
             </a:fld>
             <a:endParaRPr lang="en-US" dirty="0"/>
           </a:p>
@@ -4059,7 +4154,7 @@
           <a:p>
             <a:fld id="{C764DE79-268F-4C1A-8933-263129D2AF90}" type="datetimeFigureOut">
               <a:rPr lang="en-US" smtClean="0"/>
-              <a:t>9/28/25</a:t>
+              <a:t>10/1/25</a:t>
             </a:fld>
             <a:endParaRPr lang="en-US" dirty="0"/>
           </a:p>
@@ -4359,7 +4454,7 @@
           <a:p>
             <a:fld id="{C764DE79-268F-4C1A-8933-263129D2AF90}" type="datetimeFigureOut">
               <a:rPr lang="en-US" smtClean="0"/>
-              <a:t>9/28/25</a:t>
+              <a:t>10/1/25</a:t>
             </a:fld>
             <a:endParaRPr lang="en-US" dirty="0"/>
           </a:p>
@@ -4906,7 +5001,7 @@
           <a:p>
             <a:fld id="{C764DE79-268F-4C1A-8933-263129D2AF90}" type="datetimeFigureOut">
               <a:rPr lang="en-US" smtClean="0"/>
-              <a:t>9/28/25</a:t>
+              <a:t>10/1/25</a:t>
             </a:fld>
             <a:endParaRPr lang="en-US" dirty="0"/>
           </a:p>
@@ -5112,7 +5207,7 @@
           <a:p>
             <a:fld id="{C764DE79-268F-4C1A-8933-263129D2AF90}" type="datetimeFigureOut">
               <a:rPr lang="en-US" smtClean="0"/>
-              <a:t>9/28/25</a:t>
+              <a:t>10/1/25</a:t>
             </a:fld>
             <a:endParaRPr lang="en-US" dirty="0"/>
           </a:p>
@@ -5324,7 +5419,7 @@
           <a:p>
             <a:fld id="{C764DE79-268F-4C1A-8933-263129D2AF90}" type="datetimeFigureOut">
               <a:rPr lang="en-US" smtClean="0"/>
-              <a:t>9/28/25</a:t>
+              <a:t>10/1/25</a:t>
             </a:fld>
             <a:endParaRPr lang="en-US" dirty="0"/>
           </a:p>
@@ -5601,7 +5696,7 @@
           <a:p>
             <a:fld id="{C764DE79-268F-4C1A-8933-263129D2AF90}" type="datetimeFigureOut">
               <a:rPr lang="en-US" smtClean="0"/>
-              <a:t>9/28/25</a:t>
+              <a:t>10/1/25</a:t>
             </a:fld>
             <a:endParaRPr lang="en-US" dirty="0"/>
           </a:p>
@@ -5859,7 +5954,7 @@
           <a:p>
             <a:fld id="{C764DE79-268F-4C1A-8933-263129D2AF90}" type="datetimeFigureOut">
               <a:rPr lang="en-US" smtClean="0"/>
-              <a:t>9/28/25</a:t>
+              <a:t>10/1/25</a:t>
             </a:fld>
             <a:endParaRPr lang="en-US" dirty="0"/>
           </a:p>
@@ -6078,7 +6173,7 @@
           <a:p>
             <a:fld id="{C764DE79-268F-4C1A-8933-263129D2AF90}" type="datetimeFigureOut">
               <a:rPr lang="en-US" smtClean="0"/>
-              <a:t>9/28/25</a:t>
+              <a:t>10/1/25</a:t>
             </a:fld>
             <a:endParaRPr lang="en-US" dirty="0"/>
           </a:p>
@@ -6546,14 +6641,14 @@
           </a:ln>
           <a:extLst>
             <a:ext uri="{909E8E84-426E-40dd-AFC4-6F175D3DCCD1}">
-              <a14:hiddenFill xmlns:a14="http://schemas.microsoft.com/office/drawing/2010/main" xmlns="">
+              <a14:hiddenFill xmlns="" xmlns:a14="http://schemas.microsoft.com/office/drawing/2010/main">
                 <a:solidFill>
                   <a:srgbClr val="FFFFFF"/>
                 </a:solidFill>
               </a14:hiddenFill>
             </a:ext>
             <a:ext uri="{91240B29-F687-4f45-9708-019B960494DF}">
-              <a14:hiddenLine xmlns:a14="http://schemas.microsoft.com/office/drawing/2010/main" xmlns="" w="9525">
+              <a14:hiddenLine xmlns="" xmlns:a14="http://schemas.microsoft.com/office/drawing/2010/main" w="9525">
                 <a:solidFill>
                   <a:srgbClr val="000000"/>
                 </a:solidFill>
@@ -17326,6 +17421,1655 @@
         <p:cNvPr id="1" name="">
           <a:extLst>
             <a:ext uri="{FF2B5EF4-FFF2-40B4-BE49-F238E27FC236}">
+              <a16:creationId xmlns:a16="http://schemas.microsoft.com/office/drawing/2014/main" id="{A0D077DE-E7DD-6444-798C-7E63BF4BA3D3}"/>
+            </a:ext>
+          </a:extLst>
+        </p:cNvPr>
+        <p:cNvGrpSpPr/>
+        <p:nvPr/>
+      </p:nvGrpSpPr>
+      <p:grpSpPr>
+        <a:xfrm>
+          <a:off x="0" y="0"/>
+          <a:ext cx="0" cy="0"/>
+          <a:chOff x="0" y="0"/>
+          <a:chExt cx="0" cy="0"/>
+        </a:xfrm>
+      </p:grpSpPr>
+      <p:sp>
+        <p:nvSpPr>
+          <p:cNvPr id="2" name="Title 1">
+            <a:extLst>
+              <a:ext uri="{FF2B5EF4-FFF2-40B4-BE49-F238E27FC236}">
+                <a16:creationId xmlns:a16="http://schemas.microsoft.com/office/drawing/2014/main" id="{6B19C3C8-B1E1-49D9-3602-274237F81055}"/>
+              </a:ext>
+            </a:extLst>
+          </p:cNvPr>
+          <p:cNvSpPr>
+            <a:spLocks noGrp="1"/>
+          </p:cNvSpPr>
+          <p:nvPr>
+            <p:ph type="title"/>
+          </p:nvPr>
+        </p:nvSpPr>
+        <p:spPr/>
+        <p:txBody>
+          <a:bodyPr/>
+          <a:lstStyle/>
+          <a:p>
+            <a:r>
+              <a:rPr lang="en-IE"/>
+              <a:t>Topics list</a:t>
+            </a:r>
+            <a:endParaRPr lang="en-IE" dirty="0"/>
+          </a:p>
+        </p:txBody>
+      </p:sp>
+      <p:sp>
+        <p:nvSpPr>
+          <p:cNvPr id="5" name="Content Placeholder 4">
+            <a:extLst>
+              <a:ext uri="{FF2B5EF4-FFF2-40B4-BE49-F238E27FC236}">
+                <a16:creationId xmlns:a16="http://schemas.microsoft.com/office/drawing/2014/main" id="{EC3FAC64-F396-4275-C25B-32C453D80F88}"/>
+              </a:ext>
+            </a:extLst>
+          </p:cNvPr>
+          <p:cNvSpPr>
+            <a:spLocks noGrp="1"/>
+          </p:cNvSpPr>
+          <p:nvPr>
+            <p:ph idx="1"/>
+          </p:nvPr>
+        </p:nvSpPr>
+        <p:spPr/>
+        <p:txBody>
+          <a:bodyPr>
+            <a:normAutofit fontScale="70000" lnSpcReduction="20000"/>
+          </a:bodyPr>
+          <a:lstStyle/>
+          <a:p>
+            <a:pPr marL="514350" indent="-514350">
+              <a:buFont typeface="+mj-lt"/>
+              <a:buAutoNum type="arabicPeriod"/>
+            </a:pPr>
+            <a:r>
+              <a:rPr lang="en-IE" dirty="0"/>
+              <a:t>Variables.</a:t>
+            </a:r>
+          </a:p>
+          <a:p>
+            <a:pPr marL="514350" indent="-514350">
+              <a:buFont typeface="+mj-lt"/>
+              <a:buAutoNum type="arabicPeriod"/>
+            </a:pPr>
+            <a:endParaRPr lang="en-IE" dirty="0"/>
+          </a:p>
+          <a:p>
+            <a:pPr marL="514350" indent="-514350">
+              <a:buFont typeface="+mj-lt"/>
+              <a:buAutoNum type="arabicPeriod"/>
+            </a:pPr>
+            <a:r>
+              <a:rPr lang="en-IE" dirty="0"/>
+              <a:t>Java Keywords, tokens</a:t>
+            </a:r>
+          </a:p>
+          <a:p>
+            <a:pPr marL="514350" indent="-514350">
+              <a:buFont typeface="+mj-lt"/>
+              <a:buAutoNum type="arabicPeriod"/>
+            </a:pPr>
+            <a:endParaRPr lang="en-IE" dirty="0"/>
+          </a:p>
+          <a:p>
+            <a:pPr marL="514350" indent="-514350">
+              <a:buFont typeface="+mj-lt"/>
+              <a:buAutoNum type="arabicPeriod"/>
+            </a:pPr>
+            <a:r>
+              <a:rPr lang="en-IE" dirty="0"/>
+              <a:t>Data Types.</a:t>
+            </a:r>
+          </a:p>
+          <a:p>
+            <a:pPr marL="514350" indent="-514350">
+              <a:buFont typeface="+mj-lt"/>
+              <a:buAutoNum type="arabicPeriod"/>
+            </a:pPr>
+            <a:endParaRPr lang="en-IE" dirty="0"/>
+          </a:p>
+          <a:p>
+            <a:pPr marL="514350" indent="-514350">
+              <a:buFont typeface="+mj-lt"/>
+              <a:buAutoNum type="arabicPeriod"/>
+            </a:pPr>
+            <a:endParaRPr lang="en-IE" dirty="0"/>
+          </a:p>
+          <a:p>
+            <a:pPr marL="514350" indent="-514350">
+              <a:buFont typeface="+mj-lt"/>
+              <a:buAutoNum type="arabicPeriod"/>
+            </a:pPr>
+            <a:r>
+              <a:rPr lang="en-IE" dirty="0"/>
+              <a:t>Java’s Primitive Data Types</a:t>
+            </a:r>
+          </a:p>
+          <a:p>
+            <a:pPr marL="971550" lvl="1" indent="-514350">
+              <a:buFont typeface="+mj-lt"/>
+              <a:buAutoNum type="arabicPeriod"/>
+            </a:pPr>
+            <a:r>
+              <a:rPr lang="en-IE" dirty="0"/>
+              <a:t>Whole numbers.</a:t>
+            </a:r>
+          </a:p>
+          <a:p>
+            <a:pPr marL="971550" lvl="1" indent="-514350">
+              <a:buFont typeface="+mj-lt"/>
+              <a:buAutoNum type="arabicPeriod"/>
+            </a:pPr>
+            <a:r>
+              <a:rPr lang="en-IE" dirty="0"/>
+              <a:t>Decimal numbers.</a:t>
+            </a:r>
+          </a:p>
+          <a:p>
+            <a:pPr marL="971550" lvl="1" indent="-514350">
+              <a:buFont typeface="+mj-lt"/>
+              <a:buAutoNum type="arabicPeriod"/>
+            </a:pPr>
+            <a:r>
+              <a:rPr lang="en-IE" dirty="0"/>
+              <a:t>Others.</a:t>
+            </a:r>
+          </a:p>
+          <a:p>
+            <a:pPr marL="514350" indent="-514350">
+              <a:buFont typeface="+mj-lt"/>
+              <a:buAutoNum type="arabicPeriod"/>
+            </a:pPr>
+            <a:endParaRPr lang="en-IE" dirty="0"/>
+          </a:p>
+          <a:p>
+            <a:pPr marL="514350" indent="-514350">
+              <a:buFont typeface="+mj-lt"/>
+              <a:buAutoNum type="arabicPeriod"/>
+            </a:pPr>
+            <a:r>
+              <a:rPr lang="en-IE" dirty="0"/>
+              <a:t>Arithmetic operators.</a:t>
+            </a:r>
+          </a:p>
+        </p:txBody>
+      </p:sp>
+      <p:sp>
+        <p:nvSpPr>
+          <p:cNvPr id="4" name="Rectangle 3">
+            <a:extLst>
+              <a:ext uri="{FF2B5EF4-FFF2-40B4-BE49-F238E27FC236}">
+                <a16:creationId xmlns:a16="http://schemas.microsoft.com/office/drawing/2014/main" id="{6E188FD5-6984-F35F-9644-97A439C7C546}"/>
+              </a:ext>
+            </a:extLst>
+          </p:cNvPr>
+          <p:cNvSpPr/>
+          <p:nvPr/>
+        </p:nvSpPr>
+        <p:spPr>
+          <a:xfrm>
+            <a:off x="1055440" y="4293096"/>
+            <a:ext cx="3240360" cy="964703"/>
+          </a:xfrm>
+          <a:prstGeom prst="rect">
+            <a:avLst/>
+          </a:prstGeom>
+          <a:noFill/>
+          <a:ln w="47625">
+            <a:solidFill>
+              <a:srgbClr val="FF0000"/>
+            </a:solidFill>
+          </a:ln>
+        </p:spPr>
+        <p:style>
+          <a:lnRef idx="2">
+            <a:schemeClr val="accent1">
+              <a:shade val="50000"/>
+            </a:schemeClr>
+          </a:lnRef>
+          <a:fillRef idx="1">
+            <a:schemeClr val="accent1"/>
+          </a:fillRef>
+          <a:effectRef idx="0">
+            <a:schemeClr val="accent1"/>
+          </a:effectRef>
+          <a:fontRef idx="minor">
+            <a:schemeClr val="lt1"/>
+          </a:fontRef>
+        </p:style>
+        <p:txBody>
+          <a:bodyPr rtlCol="0" anchor="ctr"/>
+          <a:lstStyle/>
+          <a:p>
+            <a:pPr algn="ctr"/>
+            <a:endParaRPr lang="en-IE"/>
+          </a:p>
+        </p:txBody>
+      </p:sp>
+      <p:sp>
+        <p:nvSpPr>
+          <p:cNvPr id="3" name="Left Arrow 2">
+            <a:extLst>
+              <a:ext uri="{FF2B5EF4-FFF2-40B4-BE49-F238E27FC236}">
+                <a16:creationId xmlns:a16="http://schemas.microsoft.com/office/drawing/2014/main" id="{6F24353F-2838-F5D9-16BA-D48AB34B0F54}"/>
+              </a:ext>
+            </a:extLst>
+          </p:cNvPr>
+          <p:cNvSpPr/>
+          <p:nvPr/>
+        </p:nvSpPr>
+        <p:spPr>
+          <a:xfrm>
+            <a:off x="4511824" y="4972572"/>
+            <a:ext cx="2057400" cy="228600"/>
+          </a:xfrm>
+          <a:prstGeom prst="leftArrow">
+            <a:avLst/>
+          </a:prstGeom>
+        </p:spPr>
+        <p:style>
+          <a:lnRef idx="2">
+            <a:schemeClr val="accent2">
+              <a:shade val="50000"/>
+            </a:schemeClr>
+          </a:lnRef>
+          <a:fillRef idx="1">
+            <a:schemeClr val="accent2"/>
+          </a:fillRef>
+          <a:effectRef idx="0">
+            <a:schemeClr val="accent2"/>
+          </a:effectRef>
+          <a:fontRef idx="minor">
+            <a:schemeClr val="lt1"/>
+          </a:fontRef>
+        </p:style>
+        <p:txBody>
+          <a:bodyPr rtlCol="0" anchor="ctr"/>
+          <a:lstStyle/>
+          <a:p>
+            <a:pPr algn="ctr"/>
+            <a:endParaRPr lang="en-GB"/>
+          </a:p>
+        </p:txBody>
+      </p:sp>
+    </p:spTree>
+    <p:extLst>
+      <p:ext uri="{BB962C8B-B14F-4D97-AF65-F5344CB8AC3E}">
+        <p14:creationId xmlns:p14="http://schemas.microsoft.com/office/powerpoint/2010/main" val="3049901928"/>
+      </p:ext>
+    </p:extLst>
+  </p:cSld>
+  <p:clrMapOvr>
+    <a:masterClrMapping/>
+  </p:clrMapOvr>
+  <p:timing>
+    <p:tnLst>
+      <p:par>
+        <p:cTn id="1" dur="indefinite" restart="never" nodeType="tmRoot">
+          <p:childTnLst>
+            <p:seq concurrent="1" nextAc="seek">
+              <p:cTn id="2" dur="indefinite" nodeType="mainSeq">
+                <p:childTnLst>
+                  <p:par>
+                    <p:cTn id="3" fill="hold">
+                      <p:stCondLst>
+                        <p:cond delay="indefinite"/>
+                        <p:cond evt="onBegin" delay="0">
+                          <p:tn val="2"/>
+                        </p:cond>
+                      </p:stCondLst>
+                      <p:childTnLst>
+                        <p:par>
+                          <p:cTn id="4" fill="hold">
+                            <p:stCondLst>
+                              <p:cond delay="0"/>
+                            </p:stCondLst>
+                            <p:childTnLst>
+                              <p:par>
+                                <p:cTn id="5" presetID="21" presetClass="entr" presetSubtype="1" fill="hold" grpId="0" nodeType="withEffect">
+                                  <p:stCondLst>
+                                    <p:cond delay="0"/>
+                                  </p:stCondLst>
+                                  <p:childTnLst>
+                                    <p:set>
+                                      <p:cBhvr>
+                                        <p:cTn id="6" dur="1" fill="hold">
+                                          <p:stCondLst>
+                                            <p:cond delay="0"/>
+                                          </p:stCondLst>
+                                        </p:cTn>
+                                        <p:tgtEl>
+                                          <p:spTgt spid="4"/>
+                                        </p:tgtEl>
+                                        <p:attrNameLst>
+                                          <p:attrName>style.visibility</p:attrName>
+                                        </p:attrNameLst>
+                                      </p:cBhvr>
+                                      <p:to>
+                                        <p:strVal val="visible"/>
+                                      </p:to>
+                                    </p:set>
+                                    <p:animEffect transition="in" filter="wheel(1)">
+                                      <p:cBhvr>
+                                        <p:cTn id="7" dur="2000"/>
+                                        <p:tgtEl>
+                                          <p:spTgt spid="4"/>
+                                        </p:tgtEl>
+                                      </p:cBhvr>
+                                    </p:animEffect>
+                                  </p:childTnLst>
+                                </p:cTn>
+                              </p:par>
+                              <p:par>
+                                <p:cTn id="8" presetID="55" presetClass="entr" presetSubtype="0" fill="hold" grpId="0" nodeType="withEffect">
+                                  <p:stCondLst>
+                                    <p:cond delay="0"/>
+                                  </p:stCondLst>
+                                  <p:childTnLst>
+                                    <p:set>
+                                      <p:cBhvr>
+                                        <p:cTn id="9" dur="1" fill="hold">
+                                          <p:stCondLst>
+                                            <p:cond delay="0"/>
+                                          </p:stCondLst>
+                                        </p:cTn>
+                                        <p:tgtEl>
+                                          <p:spTgt spid="3"/>
+                                        </p:tgtEl>
+                                        <p:attrNameLst>
+                                          <p:attrName>style.visibility</p:attrName>
+                                        </p:attrNameLst>
+                                      </p:cBhvr>
+                                      <p:to>
+                                        <p:strVal val="visible"/>
+                                      </p:to>
+                                    </p:set>
+                                    <p:anim calcmode="lin" valueType="num">
+                                      <p:cBhvr>
+                                        <p:cTn id="10" dur="1000" fill="hold"/>
+                                        <p:tgtEl>
+                                          <p:spTgt spid="3"/>
+                                        </p:tgtEl>
+                                        <p:attrNameLst>
+                                          <p:attrName>ppt_w</p:attrName>
+                                        </p:attrNameLst>
+                                      </p:cBhvr>
+                                      <p:tavLst>
+                                        <p:tav tm="0">
+                                          <p:val>
+                                            <p:strVal val="#ppt_w*0.70"/>
+                                          </p:val>
+                                        </p:tav>
+                                        <p:tav tm="100000">
+                                          <p:val>
+                                            <p:strVal val="#ppt_w"/>
+                                          </p:val>
+                                        </p:tav>
+                                      </p:tavLst>
+                                    </p:anim>
+                                    <p:anim calcmode="lin" valueType="num">
+                                      <p:cBhvr>
+                                        <p:cTn id="11" dur="1000" fill="hold"/>
+                                        <p:tgtEl>
+                                          <p:spTgt spid="3"/>
+                                        </p:tgtEl>
+                                        <p:attrNameLst>
+                                          <p:attrName>ppt_h</p:attrName>
+                                        </p:attrNameLst>
+                                      </p:cBhvr>
+                                      <p:tavLst>
+                                        <p:tav tm="0">
+                                          <p:val>
+                                            <p:strVal val="#ppt_h"/>
+                                          </p:val>
+                                        </p:tav>
+                                        <p:tav tm="100000">
+                                          <p:val>
+                                            <p:strVal val="#ppt_h"/>
+                                          </p:val>
+                                        </p:tav>
+                                      </p:tavLst>
+                                    </p:anim>
+                                    <p:animEffect transition="in" filter="fade">
+                                      <p:cBhvr>
+                                        <p:cTn id="12" dur="1000"/>
+                                        <p:tgtEl>
+                                          <p:spTgt spid="3"/>
+                                        </p:tgtEl>
+                                      </p:cBhvr>
+                                    </p:animEffect>
+                                  </p:childTnLst>
+                                </p:cTn>
+                              </p:par>
+                            </p:childTnLst>
+                          </p:cTn>
+                        </p:par>
+                      </p:childTnLst>
+                    </p:cTn>
+                  </p:par>
+                </p:childTnLst>
+              </p:cTn>
+              <p:prevCondLst>
+                <p:cond evt="onPrev" delay="0">
+                  <p:tgtEl>
+                    <p:sldTgt/>
+                  </p:tgtEl>
+                </p:cond>
+              </p:prevCondLst>
+              <p:nextCondLst>
+                <p:cond evt="onNext" delay="0">
+                  <p:tgtEl>
+                    <p:sldTgt/>
+                  </p:tgtEl>
+                </p:cond>
+              </p:nextCondLst>
+            </p:seq>
+          </p:childTnLst>
+        </p:cTn>
+      </p:par>
+    </p:tnLst>
+    <p:bldLst>
+      <p:bldP spid="4" grpId="0" animBg="1"/>
+      <p:bldP spid="3" grpId="0" animBg="1"/>
+    </p:bldLst>
+  </p:timing>
+</p:sld>
+</file>
+
+<file path=ppt/slides/slide27.xml><?xml version="1.0" encoding="utf-8"?>
+<p:sld xmlns:a="http://schemas.openxmlformats.org/drawingml/2006/main" xmlns:r="http://schemas.openxmlformats.org/officeDocument/2006/relationships" xmlns:p="http://schemas.openxmlformats.org/presentationml/2006/main">
+  <p:cSld>
+    <p:spTree>
+      <p:nvGrpSpPr>
+        <p:cNvPr id="1" name=""/>
+        <p:cNvGrpSpPr/>
+        <p:nvPr/>
+      </p:nvGrpSpPr>
+      <p:grpSpPr>
+        <a:xfrm>
+          <a:off x="0" y="0"/>
+          <a:ext cx="0" cy="0"/>
+          <a:chOff x="0" y="0"/>
+          <a:chExt cx="0" cy="0"/>
+        </a:xfrm>
+      </p:grpSpPr>
+      <p:sp>
+        <p:nvSpPr>
+          <p:cNvPr id="36866" name="Rectangle 2"/>
+          <p:cNvSpPr>
+            <a:spLocks noGrp="1" noChangeArrowheads="1"/>
+          </p:cNvSpPr>
+          <p:nvPr>
+            <p:ph type="title"/>
+          </p:nvPr>
+        </p:nvSpPr>
+        <p:spPr/>
+        <p:txBody>
+          <a:bodyPr/>
+          <a:lstStyle/>
+          <a:p>
+            <a:r>
+              <a:rPr lang="en-US" dirty="0"/>
+              <a:t>Java’s Primitive Data Types (others)</a:t>
+            </a:r>
+          </a:p>
+        </p:txBody>
+      </p:sp>
+      <p:sp>
+        <p:nvSpPr>
+          <p:cNvPr id="36867" name="Rectangle 3"/>
+          <p:cNvSpPr>
+            <a:spLocks noGrp="1" noChangeArrowheads="1"/>
+          </p:cNvSpPr>
+          <p:nvPr>
+            <p:ph idx="1"/>
+          </p:nvPr>
+        </p:nvSpPr>
+        <p:spPr/>
+        <p:txBody>
+          <a:bodyPr>
+            <a:normAutofit/>
+          </a:bodyPr>
+          <a:lstStyle/>
+          <a:p>
+            <a:pPr marL="457200" lvl="1" indent="0">
+              <a:buNone/>
+            </a:pPr>
+            <a:endParaRPr lang="en-US" dirty="0"/>
+          </a:p>
+          <a:p>
+            <a:pPr>
+              <a:lnSpc>
+                <a:spcPct val="80000"/>
+              </a:lnSpc>
+            </a:pPr>
+            <a:endParaRPr lang="en-US" sz="2800" dirty="0"/>
+          </a:p>
+          <a:p>
+            <a:pPr>
+              <a:lnSpc>
+                <a:spcPct val="80000"/>
+              </a:lnSpc>
+            </a:pPr>
+            <a:endParaRPr lang="en-US" sz="2800" dirty="0"/>
+          </a:p>
+          <a:p>
+            <a:pPr>
+              <a:lnSpc>
+                <a:spcPct val="80000"/>
+              </a:lnSpc>
+            </a:pPr>
+            <a:endParaRPr lang="en-US" sz="2800" dirty="0"/>
+          </a:p>
+          <a:p>
+            <a:pPr>
+              <a:lnSpc>
+                <a:spcPct val="80000"/>
+              </a:lnSpc>
+            </a:pPr>
+            <a:endParaRPr lang="en-US" sz="2800" dirty="0"/>
+          </a:p>
+          <a:p>
+            <a:pPr>
+              <a:lnSpc>
+                <a:spcPct val="80000"/>
+              </a:lnSpc>
+            </a:pPr>
+            <a:endParaRPr lang="en-US" sz="2800" dirty="0"/>
+          </a:p>
+          <a:p>
+            <a:pPr>
+              <a:lnSpc>
+                <a:spcPct val="80000"/>
+              </a:lnSpc>
+            </a:pPr>
+            <a:endParaRPr lang="en-US" sz="2800" dirty="0"/>
+          </a:p>
+          <a:p>
+            <a:pPr>
+              <a:lnSpc>
+                <a:spcPct val="80000"/>
+              </a:lnSpc>
+            </a:pPr>
+            <a:endParaRPr lang="en-US" sz="2800" dirty="0"/>
+          </a:p>
+          <a:p>
+            <a:pPr>
+              <a:lnSpc>
+                <a:spcPct val="80000"/>
+              </a:lnSpc>
+            </a:pPr>
+            <a:r>
+              <a:rPr lang="en-US" sz="2800" dirty="0"/>
+              <a:t>We will go into more detail on these two data types in later lectures.</a:t>
+            </a:r>
+          </a:p>
+        </p:txBody>
+      </p:sp>
+      <p:graphicFrame>
+        <p:nvGraphicFramePr>
+          <p:cNvPr id="4" name="Table 3"/>
+          <p:cNvGraphicFramePr>
+            <a:graphicFrameLocks noGrp="1"/>
+          </p:cNvGraphicFramePr>
+          <p:nvPr/>
+        </p:nvGraphicFramePr>
+        <p:xfrm>
+          <a:off x="609600" y="1828800"/>
+          <a:ext cx="11049001" cy="2560320"/>
+        </p:xfrm>
+        <a:graphic>
+          <a:graphicData uri="http://schemas.openxmlformats.org/drawingml/2006/table">
+            <a:tbl>
+              <a:tblPr firstRow="1" bandRow="1">
+                <a:tableStyleId>{5C22544A-7EE6-4342-B048-85BDC9FD1C3A}</a:tableStyleId>
+              </a:tblPr>
+              <a:tblGrid>
+                <a:gridCol w="1371600">
+                  <a:extLst>
+                    <a:ext uri="{9D8B030D-6E8A-4147-A177-3AD203B41FA5}">
+                      <a16:colId xmlns:a16="http://schemas.microsoft.com/office/drawing/2014/main" val="20000"/>
+                    </a:ext>
+                  </a:extLst>
+                </a:gridCol>
+                <a:gridCol w="1066800">
+                  <a:extLst>
+                    <a:ext uri="{9D8B030D-6E8A-4147-A177-3AD203B41FA5}">
+                      <a16:colId xmlns:a16="http://schemas.microsoft.com/office/drawing/2014/main" val="20001"/>
+                    </a:ext>
+                  </a:extLst>
+                </a:gridCol>
+                <a:gridCol w="1371600">
+                  <a:extLst>
+                    <a:ext uri="{9D8B030D-6E8A-4147-A177-3AD203B41FA5}">
+                      <a16:colId xmlns:a16="http://schemas.microsoft.com/office/drawing/2014/main" val="20002"/>
+                    </a:ext>
+                  </a:extLst>
+                </a:gridCol>
+                <a:gridCol w="1676400">
+                  <a:extLst>
+                    <a:ext uri="{9D8B030D-6E8A-4147-A177-3AD203B41FA5}">
+                      <a16:colId xmlns:a16="http://schemas.microsoft.com/office/drawing/2014/main" val="20003"/>
+                    </a:ext>
+                  </a:extLst>
+                </a:gridCol>
+                <a:gridCol w="5562601">
+                  <a:extLst>
+                    <a:ext uri="{9D8B030D-6E8A-4147-A177-3AD203B41FA5}">
+                      <a16:colId xmlns:a16="http://schemas.microsoft.com/office/drawing/2014/main" val="20004"/>
+                    </a:ext>
+                  </a:extLst>
+                </a:gridCol>
+              </a:tblGrid>
+              <a:tr h="609600">
+                <a:tc>
+                  <a:txBody>
+                    <a:bodyPr/>
+                    <a:lstStyle/>
+                    <a:p>
+                      <a:r>
+                        <a:rPr lang="en-IE" dirty="0"/>
+                        <a:t>Type</a:t>
+                      </a:r>
+                    </a:p>
+                  </a:txBody>
+                  <a:tcPr>
+                    <a:lnL w="12700" cap="flat" cmpd="sng" algn="ctr">
+                      <a:solidFill>
+                        <a:schemeClr val="tx1"/>
+                      </a:solidFill>
+                      <a:prstDash val="solid"/>
+                      <a:round/>
+                      <a:headEnd type="none" w="med" len="med"/>
+                      <a:tailEnd type="none" w="med" len="med"/>
+                    </a:lnL>
+                    <a:lnR w="12700" cap="flat" cmpd="sng" algn="ctr">
+                      <a:solidFill>
+                        <a:schemeClr val="tx1"/>
+                      </a:solidFill>
+                      <a:prstDash val="solid"/>
+                      <a:round/>
+                      <a:headEnd type="none" w="med" len="med"/>
+                      <a:tailEnd type="none" w="med" len="med"/>
+                    </a:lnR>
+                    <a:lnT w="12700" cap="flat" cmpd="sng" algn="ctr">
+                      <a:solidFill>
+                        <a:schemeClr val="tx1"/>
+                      </a:solidFill>
+                      <a:prstDash val="solid"/>
+                      <a:round/>
+                      <a:headEnd type="none" w="med" len="med"/>
+                      <a:tailEnd type="none" w="med" len="med"/>
+                    </a:lnT>
+                    <a:lnB w="12700" cap="flat" cmpd="sng" algn="ctr">
+                      <a:solidFill>
+                        <a:schemeClr val="tx1"/>
+                      </a:solidFill>
+                      <a:prstDash val="solid"/>
+                      <a:round/>
+                      <a:headEnd type="none" w="med" len="med"/>
+                      <a:tailEnd type="none" w="med" len="med"/>
+                    </a:lnB>
+                  </a:tcPr>
+                </a:tc>
+                <a:tc>
+                  <a:txBody>
+                    <a:bodyPr/>
+                    <a:lstStyle/>
+                    <a:p>
+                      <a:r>
+                        <a:rPr lang="en-IE" dirty="0"/>
+                        <a:t>Byte-size</a:t>
+                      </a:r>
+                    </a:p>
+                  </a:txBody>
+                  <a:tcPr>
+                    <a:lnL w="12700" cap="flat" cmpd="sng" algn="ctr">
+                      <a:solidFill>
+                        <a:schemeClr val="tx1"/>
+                      </a:solidFill>
+                      <a:prstDash val="solid"/>
+                      <a:round/>
+                      <a:headEnd type="none" w="med" len="med"/>
+                      <a:tailEnd type="none" w="med" len="med"/>
+                    </a:lnL>
+                    <a:lnR w="12700" cap="flat" cmpd="sng" algn="ctr">
+                      <a:solidFill>
+                        <a:schemeClr val="tx1"/>
+                      </a:solidFill>
+                      <a:prstDash val="solid"/>
+                      <a:round/>
+                      <a:headEnd type="none" w="med" len="med"/>
+                      <a:tailEnd type="none" w="med" len="med"/>
+                    </a:lnR>
+                    <a:lnT w="12700" cap="flat" cmpd="sng" algn="ctr">
+                      <a:solidFill>
+                        <a:schemeClr val="tx1"/>
+                      </a:solidFill>
+                      <a:prstDash val="solid"/>
+                      <a:round/>
+                      <a:headEnd type="none" w="med" len="med"/>
+                      <a:tailEnd type="none" w="med" len="med"/>
+                    </a:lnT>
+                    <a:lnB w="12700" cap="flat" cmpd="sng" algn="ctr">
+                      <a:solidFill>
+                        <a:schemeClr val="tx1"/>
+                      </a:solidFill>
+                      <a:prstDash val="solid"/>
+                      <a:round/>
+                      <a:headEnd type="none" w="med" len="med"/>
+                      <a:tailEnd type="none" w="med" len="med"/>
+                    </a:lnB>
+                  </a:tcPr>
+                </a:tc>
+                <a:tc>
+                  <a:txBody>
+                    <a:bodyPr/>
+                    <a:lstStyle/>
+                    <a:p>
+                      <a:r>
+                        <a:rPr lang="en-IE" dirty="0"/>
+                        <a:t>Minimum value</a:t>
+                      </a:r>
+                      <a:r>
+                        <a:rPr lang="en-IE" baseline="0" dirty="0"/>
+                        <a:t> (inclusive)</a:t>
+                      </a:r>
+                      <a:endParaRPr lang="en-IE" dirty="0"/>
+                    </a:p>
+                  </a:txBody>
+                  <a:tcPr>
+                    <a:lnL w="12700" cap="flat" cmpd="sng" algn="ctr">
+                      <a:solidFill>
+                        <a:schemeClr val="tx1"/>
+                      </a:solidFill>
+                      <a:prstDash val="solid"/>
+                      <a:round/>
+                      <a:headEnd type="none" w="med" len="med"/>
+                      <a:tailEnd type="none" w="med" len="med"/>
+                    </a:lnL>
+                    <a:lnR w="12700" cap="flat" cmpd="sng" algn="ctr">
+                      <a:solidFill>
+                        <a:schemeClr val="tx1"/>
+                      </a:solidFill>
+                      <a:prstDash val="solid"/>
+                      <a:round/>
+                      <a:headEnd type="none" w="med" len="med"/>
+                      <a:tailEnd type="none" w="med" len="med"/>
+                    </a:lnR>
+                    <a:lnT w="12700" cap="flat" cmpd="sng" algn="ctr">
+                      <a:solidFill>
+                        <a:schemeClr val="tx1"/>
+                      </a:solidFill>
+                      <a:prstDash val="solid"/>
+                      <a:round/>
+                      <a:headEnd type="none" w="med" len="med"/>
+                      <a:tailEnd type="none" w="med" len="med"/>
+                    </a:lnT>
+                    <a:lnB w="12700" cap="flat" cmpd="sng" algn="ctr">
+                      <a:solidFill>
+                        <a:schemeClr val="tx1"/>
+                      </a:solidFill>
+                      <a:prstDash val="solid"/>
+                      <a:round/>
+                      <a:headEnd type="none" w="med" len="med"/>
+                      <a:tailEnd type="none" w="med" len="med"/>
+                    </a:lnB>
+                  </a:tcPr>
+                </a:tc>
+                <a:tc>
+                  <a:txBody>
+                    <a:bodyPr/>
+                    <a:lstStyle/>
+                    <a:p>
+                      <a:r>
+                        <a:rPr lang="en-IE" dirty="0"/>
+                        <a:t>Maximum value </a:t>
+                      </a:r>
+                      <a:r>
+                        <a:rPr lang="en-IE" baseline="0" dirty="0"/>
+                        <a:t>(inclusive)</a:t>
+                      </a:r>
+                      <a:endParaRPr lang="en-IE" dirty="0"/>
+                    </a:p>
+                  </a:txBody>
+                  <a:tcPr>
+                    <a:lnL w="12700" cap="flat" cmpd="sng" algn="ctr">
+                      <a:solidFill>
+                        <a:schemeClr val="tx1"/>
+                      </a:solidFill>
+                      <a:prstDash val="solid"/>
+                      <a:round/>
+                      <a:headEnd type="none" w="med" len="med"/>
+                      <a:tailEnd type="none" w="med" len="med"/>
+                    </a:lnL>
+                    <a:lnR w="12700" cap="flat" cmpd="sng" algn="ctr">
+                      <a:solidFill>
+                        <a:schemeClr val="tx1"/>
+                      </a:solidFill>
+                      <a:prstDash val="solid"/>
+                      <a:round/>
+                      <a:headEnd type="none" w="med" len="med"/>
+                      <a:tailEnd type="none" w="med" len="med"/>
+                    </a:lnR>
+                    <a:lnT w="12700" cap="flat" cmpd="sng" algn="ctr">
+                      <a:solidFill>
+                        <a:schemeClr val="tx1"/>
+                      </a:solidFill>
+                      <a:prstDash val="solid"/>
+                      <a:round/>
+                      <a:headEnd type="none" w="med" len="med"/>
+                      <a:tailEnd type="none" w="med" len="med"/>
+                    </a:lnT>
+                    <a:lnB w="12700" cap="flat" cmpd="sng" algn="ctr">
+                      <a:solidFill>
+                        <a:schemeClr val="tx1"/>
+                      </a:solidFill>
+                      <a:prstDash val="solid"/>
+                      <a:round/>
+                      <a:headEnd type="none" w="med" len="med"/>
+                      <a:tailEnd type="none" w="med" len="med"/>
+                    </a:lnB>
+                  </a:tcPr>
+                </a:tc>
+                <a:tc>
+                  <a:txBody>
+                    <a:bodyPr/>
+                    <a:lstStyle/>
+                    <a:p>
+                      <a:r>
+                        <a:rPr lang="en-IE" dirty="0"/>
+                        <a:t>Typical Use</a:t>
+                      </a:r>
+                    </a:p>
+                  </a:txBody>
+                  <a:tcPr>
+                    <a:lnL w="12700" cap="flat" cmpd="sng" algn="ctr">
+                      <a:solidFill>
+                        <a:schemeClr val="tx1"/>
+                      </a:solidFill>
+                      <a:prstDash val="solid"/>
+                      <a:round/>
+                      <a:headEnd type="none" w="med" len="med"/>
+                      <a:tailEnd type="none" w="med" len="med"/>
+                    </a:lnL>
+                    <a:lnR w="12700" cap="flat" cmpd="sng" algn="ctr">
+                      <a:solidFill>
+                        <a:schemeClr val="tx1"/>
+                      </a:solidFill>
+                      <a:prstDash val="solid"/>
+                      <a:round/>
+                      <a:headEnd type="none" w="med" len="med"/>
+                      <a:tailEnd type="none" w="med" len="med"/>
+                    </a:lnR>
+                    <a:lnT w="12700" cap="flat" cmpd="sng" algn="ctr">
+                      <a:solidFill>
+                        <a:schemeClr val="tx1"/>
+                      </a:solidFill>
+                      <a:prstDash val="solid"/>
+                      <a:round/>
+                      <a:headEnd type="none" w="med" len="med"/>
+                      <a:tailEnd type="none" w="med" len="med"/>
+                    </a:lnT>
+                    <a:lnB w="12700" cap="flat" cmpd="sng" algn="ctr">
+                      <a:solidFill>
+                        <a:schemeClr val="tx1"/>
+                      </a:solidFill>
+                      <a:prstDash val="solid"/>
+                      <a:round/>
+                      <a:headEnd type="none" w="med" len="med"/>
+                      <a:tailEnd type="none" w="med" len="med"/>
+                    </a:lnB>
+                  </a:tcPr>
+                </a:tc>
+                <a:extLst>
+                  <a:ext uri="{0D108BD9-81ED-4DB2-BD59-A6C34878D82A}">
+                    <a16:rowId xmlns:a16="http://schemas.microsoft.com/office/drawing/2014/main" val="10000"/>
+                  </a:ext>
+                </a:extLst>
+              </a:tr>
+              <a:tr h="589280">
+                <a:tc>
+                  <a:txBody>
+                    <a:bodyPr/>
+                    <a:lstStyle/>
+                    <a:p>
+                      <a:r>
+                        <a:rPr lang="en-IE" sz="2400" dirty="0">
+                          <a:solidFill>
+                            <a:srgbClr val="FF0000"/>
+                          </a:solidFill>
+                        </a:rPr>
+                        <a:t>char</a:t>
+                      </a:r>
+                    </a:p>
+                  </a:txBody>
+                  <a:tcPr>
+                    <a:lnL w="12700" cap="flat" cmpd="sng" algn="ctr">
+                      <a:solidFill>
+                        <a:schemeClr val="tx1"/>
+                      </a:solidFill>
+                      <a:prstDash val="solid"/>
+                      <a:round/>
+                      <a:headEnd type="none" w="med" len="med"/>
+                      <a:tailEnd type="none" w="med" len="med"/>
+                    </a:lnL>
+                    <a:lnR w="12700" cap="flat" cmpd="sng" algn="ctr">
+                      <a:solidFill>
+                        <a:schemeClr val="tx1"/>
+                      </a:solidFill>
+                      <a:prstDash val="solid"/>
+                      <a:round/>
+                      <a:headEnd type="none" w="med" len="med"/>
+                      <a:tailEnd type="none" w="med" len="med"/>
+                    </a:lnR>
+                    <a:lnT w="12700" cap="flat" cmpd="sng" algn="ctr">
+                      <a:solidFill>
+                        <a:schemeClr val="tx1"/>
+                      </a:solidFill>
+                      <a:prstDash val="solid"/>
+                      <a:round/>
+                      <a:headEnd type="none" w="med" len="med"/>
+                      <a:tailEnd type="none" w="med" len="med"/>
+                    </a:lnT>
+                    <a:lnB w="12700" cap="flat" cmpd="sng" algn="ctr">
+                      <a:solidFill>
+                        <a:schemeClr val="tx1"/>
+                      </a:solidFill>
+                      <a:prstDash val="solid"/>
+                      <a:round/>
+                      <a:headEnd type="none" w="med" len="med"/>
+                      <a:tailEnd type="none" w="med" len="med"/>
+                    </a:lnB>
+                  </a:tcPr>
+                </a:tc>
+                <a:tc>
+                  <a:txBody>
+                    <a:bodyPr/>
+                    <a:lstStyle/>
+                    <a:p>
+                      <a:pPr algn="ctr"/>
+                      <a:r>
+                        <a:rPr lang="en-IE" sz="2400" dirty="0"/>
+                        <a:t>16-bit</a:t>
+                      </a:r>
+                    </a:p>
+                  </a:txBody>
+                  <a:tcPr>
+                    <a:lnL w="12700" cap="flat" cmpd="sng" algn="ctr">
+                      <a:solidFill>
+                        <a:schemeClr val="tx1"/>
+                      </a:solidFill>
+                      <a:prstDash val="solid"/>
+                      <a:round/>
+                      <a:headEnd type="none" w="med" len="med"/>
+                      <a:tailEnd type="none" w="med" len="med"/>
+                    </a:lnL>
+                    <a:lnR w="12700" cap="flat" cmpd="sng" algn="ctr">
+                      <a:solidFill>
+                        <a:schemeClr val="tx1"/>
+                      </a:solidFill>
+                      <a:prstDash val="solid"/>
+                      <a:round/>
+                      <a:headEnd type="none" w="med" len="med"/>
+                      <a:tailEnd type="none" w="med" len="med"/>
+                    </a:lnR>
+                    <a:lnT w="12700" cap="flat" cmpd="sng" algn="ctr">
+                      <a:solidFill>
+                        <a:schemeClr val="tx1"/>
+                      </a:solidFill>
+                      <a:prstDash val="solid"/>
+                      <a:round/>
+                      <a:headEnd type="none" w="med" len="med"/>
+                      <a:tailEnd type="none" w="med" len="med"/>
+                    </a:lnT>
+                    <a:lnB w="12700" cap="flat" cmpd="sng" algn="ctr">
+                      <a:solidFill>
+                        <a:schemeClr val="tx1"/>
+                      </a:solidFill>
+                      <a:prstDash val="solid"/>
+                      <a:round/>
+                      <a:headEnd type="none" w="med" len="med"/>
+                      <a:tailEnd type="none" w="med" len="med"/>
+                    </a:lnB>
+                  </a:tcPr>
+                </a:tc>
+                <a:tc>
+                  <a:txBody>
+                    <a:bodyPr/>
+                    <a:lstStyle/>
+                    <a:p>
+                      <a:pPr marL="0" algn="l" defTabSz="914400" rtl="0" eaLnBrk="1" latinLnBrk="0" hangingPunct="1"/>
+                      <a:r>
+                        <a:rPr lang="en-IE" sz="2400" kern="1200" dirty="0">
+                          <a:solidFill>
+                            <a:schemeClr val="dk1"/>
+                          </a:solidFill>
+                          <a:latin typeface="+mn-lt"/>
+                          <a:ea typeface="+mn-ea"/>
+                          <a:cs typeface="+mn-cs"/>
+                        </a:rPr>
+                        <a:t>'\u0000'</a:t>
+                      </a:r>
+                    </a:p>
+                    <a:p>
+                      <a:pPr marL="0" algn="l" defTabSz="914400" rtl="0" eaLnBrk="1" latinLnBrk="0" hangingPunct="1"/>
+                      <a:r>
+                        <a:rPr lang="en-IE" sz="2400" kern="1200" dirty="0">
+                          <a:solidFill>
+                            <a:schemeClr val="dk1"/>
+                          </a:solidFill>
+                          <a:latin typeface="+mn-lt"/>
+                          <a:ea typeface="+mn-ea"/>
+                          <a:cs typeface="+mn-cs"/>
+                        </a:rPr>
+                        <a:t>(or 0) </a:t>
+                      </a:r>
+                    </a:p>
+                  </a:txBody>
+                  <a:tcPr>
+                    <a:lnL w="12700" cap="flat" cmpd="sng" algn="ctr">
+                      <a:solidFill>
+                        <a:schemeClr val="tx1"/>
+                      </a:solidFill>
+                      <a:prstDash val="solid"/>
+                      <a:round/>
+                      <a:headEnd type="none" w="med" len="med"/>
+                      <a:tailEnd type="none" w="med" len="med"/>
+                    </a:lnL>
+                    <a:lnR w="12700" cap="flat" cmpd="sng" algn="ctr">
+                      <a:solidFill>
+                        <a:schemeClr val="tx1"/>
+                      </a:solidFill>
+                      <a:prstDash val="solid"/>
+                      <a:round/>
+                      <a:headEnd type="none" w="med" len="med"/>
+                      <a:tailEnd type="none" w="med" len="med"/>
+                    </a:lnR>
+                    <a:lnT w="12700" cap="flat" cmpd="sng" algn="ctr">
+                      <a:solidFill>
+                        <a:schemeClr val="tx1"/>
+                      </a:solidFill>
+                      <a:prstDash val="solid"/>
+                      <a:round/>
+                      <a:headEnd type="none" w="med" len="med"/>
+                      <a:tailEnd type="none" w="med" len="med"/>
+                    </a:lnT>
+                    <a:lnB w="12700" cap="flat" cmpd="sng" algn="ctr">
+                      <a:solidFill>
+                        <a:schemeClr val="tx1"/>
+                      </a:solidFill>
+                      <a:prstDash val="solid"/>
+                      <a:round/>
+                      <a:headEnd type="none" w="med" len="med"/>
+                      <a:tailEnd type="none" w="med" len="med"/>
+                    </a:lnB>
+                  </a:tcPr>
+                </a:tc>
+                <a:tc>
+                  <a:txBody>
+                    <a:bodyPr/>
+                    <a:lstStyle/>
+                    <a:p>
+                      <a:pPr marL="0" algn="l" defTabSz="914400" rtl="0" eaLnBrk="1" latinLnBrk="0" hangingPunct="1"/>
+                      <a:r>
+                        <a:rPr lang="en-IE" sz="2400" kern="1200" dirty="0">
+                          <a:solidFill>
+                            <a:schemeClr val="dk1"/>
+                          </a:solidFill>
+                          <a:latin typeface="+mn-lt"/>
+                          <a:ea typeface="+mn-ea"/>
+                          <a:cs typeface="+mn-cs"/>
+                        </a:rPr>
+                        <a:t>'\</a:t>
+                      </a:r>
+                      <a:r>
+                        <a:rPr lang="en-IE" sz="2400" kern="1200" dirty="0" err="1">
+                          <a:solidFill>
+                            <a:schemeClr val="dk1"/>
+                          </a:solidFill>
+                          <a:latin typeface="+mn-lt"/>
+                          <a:ea typeface="+mn-ea"/>
+                          <a:cs typeface="+mn-cs"/>
+                        </a:rPr>
+                        <a:t>uffff</a:t>
+                      </a:r>
+                      <a:r>
+                        <a:rPr lang="en-IE" sz="2400" kern="1200" dirty="0">
+                          <a:solidFill>
+                            <a:schemeClr val="dk1"/>
+                          </a:solidFill>
+                          <a:latin typeface="+mn-lt"/>
+                          <a:ea typeface="+mn-ea"/>
+                          <a:cs typeface="+mn-cs"/>
+                        </a:rPr>
+                        <a:t>' </a:t>
+                      </a:r>
+                    </a:p>
+                    <a:p>
+                      <a:pPr marL="0" algn="l" defTabSz="914400" rtl="0" eaLnBrk="1" latinLnBrk="0" hangingPunct="1"/>
+                      <a:r>
+                        <a:rPr lang="en-IE" sz="2400" kern="1200" dirty="0">
+                          <a:solidFill>
+                            <a:schemeClr val="dk1"/>
+                          </a:solidFill>
+                          <a:latin typeface="+mn-lt"/>
+                          <a:ea typeface="+mn-ea"/>
+                          <a:cs typeface="+mn-cs"/>
+                        </a:rPr>
+                        <a:t>(or 65,535)</a:t>
+                      </a:r>
+                    </a:p>
+                  </a:txBody>
+                  <a:tcPr>
+                    <a:lnL w="12700" cap="flat" cmpd="sng" algn="ctr">
+                      <a:solidFill>
+                        <a:schemeClr val="tx1"/>
+                      </a:solidFill>
+                      <a:prstDash val="solid"/>
+                      <a:round/>
+                      <a:headEnd type="none" w="med" len="med"/>
+                      <a:tailEnd type="none" w="med" len="med"/>
+                    </a:lnL>
+                    <a:lnR w="12700" cap="flat" cmpd="sng" algn="ctr">
+                      <a:solidFill>
+                        <a:schemeClr val="tx1"/>
+                      </a:solidFill>
+                      <a:prstDash val="solid"/>
+                      <a:round/>
+                      <a:headEnd type="none" w="med" len="med"/>
+                      <a:tailEnd type="none" w="med" len="med"/>
+                    </a:lnR>
+                    <a:lnT w="12700" cap="flat" cmpd="sng" algn="ctr">
+                      <a:solidFill>
+                        <a:schemeClr val="tx1"/>
+                      </a:solidFill>
+                      <a:prstDash val="solid"/>
+                      <a:round/>
+                      <a:headEnd type="none" w="med" len="med"/>
+                      <a:tailEnd type="none" w="med" len="med"/>
+                    </a:lnT>
+                    <a:lnB w="12700" cap="flat" cmpd="sng" algn="ctr">
+                      <a:solidFill>
+                        <a:schemeClr val="tx1"/>
+                      </a:solidFill>
+                      <a:prstDash val="solid"/>
+                      <a:round/>
+                      <a:headEnd type="none" w="med" len="med"/>
+                      <a:tailEnd type="none" w="med" len="med"/>
+                    </a:lnB>
+                  </a:tcPr>
+                </a:tc>
+                <a:tc>
+                  <a:txBody>
+                    <a:bodyPr/>
+                    <a:lstStyle/>
+                    <a:p>
+                      <a:pPr marL="0" algn="l" defTabSz="914400" rtl="0" eaLnBrk="1" latinLnBrk="0" hangingPunct="1"/>
+                      <a:r>
+                        <a:rPr lang="en-IE" sz="2400" kern="1200" dirty="0">
+                          <a:solidFill>
+                            <a:schemeClr val="dk1"/>
+                          </a:solidFill>
+                          <a:latin typeface="+mn-lt"/>
+                          <a:ea typeface="+mn-ea"/>
+                          <a:cs typeface="+mn-cs"/>
+                        </a:rPr>
+                        <a:t>Represents a Unicode character.</a:t>
+                      </a:r>
+                    </a:p>
+                  </a:txBody>
+                  <a:tcPr>
+                    <a:lnL w="12700" cap="flat" cmpd="sng" algn="ctr">
+                      <a:solidFill>
+                        <a:schemeClr val="tx1"/>
+                      </a:solidFill>
+                      <a:prstDash val="solid"/>
+                      <a:round/>
+                      <a:headEnd type="none" w="med" len="med"/>
+                      <a:tailEnd type="none" w="med" len="med"/>
+                    </a:lnL>
+                    <a:lnR w="12700" cap="flat" cmpd="sng" algn="ctr">
+                      <a:solidFill>
+                        <a:schemeClr val="tx1"/>
+                      </a:solidFill>
+                      <a:prstDash val="solid"/>
+                      <a:round/>
+                      <a:headEnd type="none" w="med" len="med"/>
+                      <a:tailEnd type="none" w="med" len="med"/>
+                    </a:lnR>
+                    <a:lnT w="12700" cap="flat" cmpd="sng" algn="ctr">
+                      <a:solidFill>
+                        <a:schemeClr val="tx1"/>
+                      </a:solidFill>
+                      <a:prstDash val="solid"/>
+                      <a:round/>
+                      <a:headEnd type="none" w="med" len="med"/>
+                      <a:tailEnd type="none" w="med" len="med"/>
+                    </a:lnT>
+                    <a:lnB w="12700" cap="flat" cmpd="sng" algn="ctr">
+                      <a:solidFill>
+                        <a:schemeClr val="tx1"/>
+                      </a:solidFill>
+                      <a:prstDash val="solid"/>
+                      <a:round/>
+                      <a:headEnd type="none" w="med" len="med"/>
+                      <a:tailEnd type="none" w="med" len="med"/>
+                    </a:lnB>
+                  </a:tcPr>
+                </a:tc>
+                <a:extLst>
+                  <a:ext uri="{0D108BD9-81ED-4DB2-BD59-A6C34878D82A}">
+                    <a16:rowId xmlns:a16="http://schemas.microsoft.com/office/drawing/2014/main" val="10001"/>
+                  </a:ext>
+                </a:extLst>
+              </a:tr>
+              <a:tr h="589280">
+                <a:tc>
+                  <a:txBody>
+                    <a:bodyPr/>
+                    <a:lstStyle/>
+                    <a:p>
+                      <a:endParaRPr lang="en-IE" sz="2400" dirty="0">
+                        <a:solidFill>
+                          <a:srgbClr val="FF0000"/>
+                        </a:solidFill>
+                      </a:endParaRPr>
+                    </a:p>
+                    <a:p>
+                      <a:r>
+                        <a:rPr lang="en-IE" sz="2400" dirty="0" err="1">
+                          <a:solidFill>
+                            <a:srgbClr val="FF0000"/>
+                          </a:solidFill>
+                        </a:rPr>
+                        <a:t>boolean</a:t>
+                      </a:r>
+                      <a:endParaRPr lang="en-IE" sz="2400" dirty="0">
+                        <a:solidFill>
+                          <a:srgbClr val="FF0000"/>
+                        </a:solidFill>
+                      </a:endParaRPr>
+                    </a:p>
+                  </a:txBody>
+                  <a:tcPr>
+                    <a:lnL w="12700" cap="flat" cmpd="sng" algn="ctr">
+                      <a:solidFill>
+                        <a:schemeClr val="tx1"/>
+                      </a:solidFill>
+                      <a:prstDash val="solid"/>
+                      <a:round/>
+                      <a:headEnd type="none" w="med" len="med"/>
+                      <a:tailEnd type="none" w="med" len="med"/>
+                    </a:lnL>
+                    <a:lnR w="12700" cap="flat" cmpd="sng" algn="ctr">
+                      <a:solidFill>
+                        <a:schemeClr val="tx1"/>
+                      </a:solidFill>
+                      <a:prstDash val="solid"/>
+                      <a:round/>
+                      <a:headEnd type="none" w="med" len="med"/>
+                      <a:tailEnd type="none" w="med" len="med"/>
+                    </a:lnR>
+                    <a:lnT w="12700" cap="flat" cmpd="sng" algn="ctr">
+                      <a:solidFill>
+                        <a:schemeClr val="tx1"/>
+                      </a:solidFill>
+                      <a:prstDash val="solid"/>
+                      <a:round/>
+                      <a:headEnd type="none" w="med" len="med"/>
+                      <a:tailEnd type="none" w="med" len="med"/>
+                    </a:lnT>
+                    <a:lnB w="12700" cap="flat" cmpd="sng" algn="ctr">
+                      <a:solidFill>
+                        <a:schemeClr val="tx1"/>
+                      </a:solidFill>
+                      <a:prstDash val="solid"/>
+                      <a:round/>
+                      <a:headEnd type="none" w="med" len="med"/>
+                      <a:tailEnd type="none" w="med" len="med"/>
+                    </a:lnB>
+                  </a:tcPr>
+                </a:tc>
+                <a:tc>
+                  <a:txBody>
+                    <a:bodyPr/>
+                    <a:lstStyle/>
+                    <a:p>
+                      <a:pPr algn="ctr"/>
+                      <a:endParaRPr lang="en-IE" sz="2400" dirty="0"/>
+                    </a:p>
+                    <a:p>
+                      <a:pPr algn="ctr"/>
+                      <a:r>
+                        <a:rPr lang="en-IE" sz="2400" dirty="0"/>
+                        <a:t>1-bit</a:t>
+                      </a:r>
+                    </a:p>
+                  </a:txBody>
+                  <a:tcPr>
+                    <a:lnL w="12700" cap="flat" cmpd="sng" algn="ctr">
+                      <a:solidFill>
+                        <a:schemeClr val="tx1"/>
+                      </a:solidFill>
+                      <a:prstDash val="solid"/>
+                      <a:round/>
+                      <a:headEnd type="none" w="med" len="med"/>
+                      <a:tailEnd type="none" w="med" len="med"/>
+                    </a:lnL>
+                    <a:lnR w="12700" cap="flat" cmpd="sng" algn="ctr">
+                      <a:solidFill>
+                        <a:schemeClr val="tx1"/>
+                      </a:solidFill>
+                      <a:prstDash val="solid"/>
+                      <a:round/>
+                      <a:headEnd type="none" w="med" len="med"/>
+                      <a:tailEnd type="none" w="med" len="med"/>
+                    </a:lnR>
+                    <a:lnT w="12700" cap="flat" cmpd="sng" algn="ctr">
+                      <a:solidFill>
+                        <a:schemeClr val="tx1"/>
+                      </a:solidFill>
+                      <a:prstDash val="solid"/>
+                      <a:round/>
+                      <a:headEnd type="none" w="med" len="med"/>
+                      <a:tailEnd type="none" w="med" len="med"/>
+                    </a:lnT>
+                    <a:lnB w="12700" cap="flat" cmpd="sng" algn="ctr">
+                      <a:solidFill>
+                        <a:schemeClr val="tx1"/>
+                      </a:solidFill>
+                      <a:prstDash val="solid"/>
+                      <a:round/>
+                      <a:headEnd type="none" w="med" len="med"/>
+                      <a:tailEnd type="none" w="med" len="med"/>
+                    </a:lnB>
+                  </a:tcPr>
+                </a:tc>
+                <a:tc gridSpan="2">
+                  <a:txBody>
+                    <a:bodyPr/>
+                    <a:lstStyle/>
+                    <a:p>
+                      <a:pPr marL="0" algn="ctr" defTabSz="914400" rtl="0" eaLnBrk="1" latinLnBrk="0" hangingPunct="1"/>
+                      <a:endParaRPr lang="en-IE" sz="2400" kern="1200" dirty="0">
+                        <a:solidFill>
+                          <a:schemeClr val="dk1"/>
+                        </a:solidFill>
+                        <a:latin typeface="+mn-lt"/>
+                        <a:ea typeface="+mn-ea"/>
+                        <a:cs typeface="+mn-cs"/>
+                      </a:endParaRPr>
+                    </a:p>
+                    <a:p>
+                      <a:pPr marL="0" algn="ctr" defTabSz="914400" rtl="0" eaLnBrk="1" latinLnBrk="0" hangingPunct="1"/>
+                      <a:r>
+                        <a:rPr lang="en-IE" sz="2400" kern="1200" dirty="0">
+                          <a:solidFill>
+                            <a:schemeClr val="dk1"/>
+                          </a:solidFill>
+                          <a:latin typeface="+mn-lt"/>
+                          <a:ea typeface="+mn-ea"/>
+                          <a:cs typeface="+mn-cs"/>
+                        </a:rPr>
+                        <a:t>n/a</a:t>
+                      </a:r>
+                    </a:p>
+                  </a:txBody>
+                  <a:tcPr>
+                    <a:lnL w="12700" cap="flat" cmpd="sng" algn="ctr">
+                      <a:solidFill>
+                        <a:schemeClr val="tx1"/>
+                      </a:solidFill>
+                      <a:prstDash val="solid"/>
+                      <a:round/>
+                      <a:headEnd type="none" w="med" len="med"/>
+                      <a:tailEnd type="none" w="med" len="med"/>
+                    </a:lnL>
+                    <a:lnR w="12700" cap="flat" cmpd="sng" algn="ctr">
+                      <a:solidFill>
+                        <a:schemeClr val="tx1"/>
+                      </a:solidFill>
+                      <a:prstDash val="solid"/>
+                      <a:round/>
+                      <a:headEnd type="none" w="med" len="med"/>
+                      <a:tailEnd type="none" w="med" len="med"/>
+                    </a:lnR>
+                    <a:lnT w="12700" cap="flat" cmpd="sng" algn="ctr">
+                      <a:solidFill>
+                        <a:schemeClr val="tx1"/>
+                      </a:solidFill>
+                      <a:prstDash val="solid"/>
+                      <a:round/>
+                      <a:headEnd type="none" w="med" len="med"/>
+                      <a:tailEnd type="none" w="med" len="med"/>
+                    </a:lnT>
+                    <a:lnB w="12700" cap="flat" cmpd="sng" algn="ctr">
+                      <a:solidFill>
+                        <a:schemeClr val="tx1"/>
+                      </a:solidFill>
+                      <a:prstDash val="solid"/>
+                      <a:round/>
+                      <a:headEnd type="none" w="med" len="med"/>
+                      <a:tailEnd type="none" w="med" len="med"/>
+                    </a:lnB>
+                  </a:tcPr>
+                </a:tc>
+                <a:tc hMerge="1">
+                  <a:txBody>
+                    <a:bodyPr/>
+                    <a:lstStyle/>
+                    <a:p>
+                      <a:pPr marL="0" algn="l" defTabSz="914400" rtl="0" eaLnBrk="1" latinLnBrk="0" hangingPunct="1"/>
+                      <a:endParaRPr lang="en-IE" sz="3200" kern="1200" dirty="0">
+                        <a:solidFill>
+                          <a:schemeClr val="dk1"/>
+                        </a:solidFill>
+                        <a:latin typeface="+mn-lt"/>
+                        <a:ea typeface="+mn-ea"/>
+                        <a:cs typeface="+mn-cs"/>
+                      </a:endParaRPr>
+                    </a:p>
+                  </a:txBody>
+                  <a:tcPr/>
+                </a:tc>
+                <a:tc>
+                  <a:txBody>
+                    <a:bodyPr/>
+                    <a:lstStyle/>
+                    <a:p>
+                      <a:pPr marL="0" algn="l" defTabSz="914400" rtl="0" eaLnBrk="1" latinLnBrk="0" hangingPunct="1"/>
+                      <a:r>
+                        <a:rPr lang="en-IE" sz="2400" kern="1200" dirty="0">
+                          <a:solidFill>
+                            <a:schemeClr val="dk1"/>
+                          </a:solidFill>
+                          <a:latin typeface="+mn-lt"/>
+                          <a:ea typeface="+mn-ea"/>
+                          <a:cs typeface="+mn-cs"/>
+                        </a:rPr>
+                        <a:t>Holds either </a:t>
+                      </a:r>
+                      <a:r>
+                        <a:rPr lang="en-IE" sz="2400" b="1" kern="1200" dirty="0">
+                          <a:solidFill>
+                            <a:schemeClr val="dk1"/>
+                          </a:solidFill>
+                          <a:latin typeface="+mn-lt"/>
+                          <a:ea typeface="+mn-ea"/>
+                          <a:cs typeface="+mn-cs"/>
+                        </a:rPr>
+                        <a:t>true</a:t>
+                      </a:r>
+                      <a:r>
+                        <a:rPr lang="en-IE" sz="2400" kern="1200" dirty="0">
+                          <a:solidFill>
+                            <a:schemeClr val="dk1"/>
+                          </a:solidFill>
+                          <a:latin typeface="+mn-lt"/>
+                          <a:ea typeface="+mn-ea"/>
+                          <a:cs typeface="+mn-cs"/>
+                        </a:rPr>
+                        <a:t> or </a:t>
+                      </a:r>
+                      <a:r>
+                        <a:rPr lang="en-IE" sz="2400" b="1" kern="1200" dirty="0">
+                          <a:solidFill>
+                            <a:schemeClr val="dk1"/>
+                          </a:solidFill>
+                          <a:latin typeface="+mn-lt"/>
+                          <a:ea typeface="+mn-ea"/>
+                          <a:cs typeface="+mn-cs"/>
+                        </a:rPr>
+                        <a:t>false</a:t>
+                      </a:r>
+                      <a:r>
+                        <a:rPr lang="en-IE" sz="2400" kern="1200" dirty="0">
+                          <a:solidFill>
+                            <a:schemeClr val="dk1"/>
+                          </a:solidFill>
+                          <a:latin typeface="+mn-lt"/>
+                          <a:ea typeface="+mn-ea"/>
+                          <a:cs typeface="+mn-cs"/>
+                        </a:rPr>
+                        <a:t> </a:t>
+                      </a:r>
+                      <a:br>
+                        <a:rPr lang="en-IE" sz="2400" kern="1200" dirty="0">
+                          <a:solidFill>
+                            <a:schemeClr val="dk1"/>
+                          </a:solidFill>
+                          <a:latin typeface="+mn-lt"/>
+                          <a:ea typeface="+mn-ea"/>
+                          <a:cs typeface="+mn-cs"/>
+                        </a:rPr>
+                      </a:br>
+                      <a:r>
+                        <a:rPr lang="en-IE" sz="2400" kern="1200" dirty="0">
+                          <a:solidFill>
+                            <a:schemeClr val="dk1"/>
+                          </a:solidFill>
+                          <a:latin typeface="+mn-lt"/>
+                          <a:ea typeface="+mn-ea"/>
+                          <a:cs typeface="+mn-cs"/>
+                        </a:rPr>
+                        <a:t>and is typically used as a flag.</a:t>
+                      </a:r>
+                    </a:p>
+                  </a:txBody>
+                  <a:tcPr>
+                    <a:lnL w="12700" cap="flat" cmpd="sng" algn="ctr">
+                      <a:solidFill>
+                        <a:schemeClr val="tx1"/>
+                      </a:solidFill>
+                      <a:prstDash val="solid"/>
+                      <a:round/>
+                      <a:headEnd type="none" w="med" len="med"/>
+                      <a:tailEnd type="none" w="med" len="med"/>
+                    </a:lnL>
+                    <a:lnR w="12700" cap="flat" cmpd="sng" algn="ctr">
+                      <a:solidFill>
+                        <a:schemeClr val="tx1"/>
+                      </a:solidFill>
+                      <a:prstDash val="solid"/>
+                      <a:round/>
+                      <a:headEnd type="none" w="med" len="med"/>
+                      <a:tailEnd type="none" w="med" len="med"/>
+                    </a:lnR>
+                    <a:lnT w="12700" cap="flat" cmpd="sng" algn="ctr">
+                      <a:solidFill>
+                        <a:schemeClr val="tx1"/>
+                      </a:solidFill>
+                      <a:prstDash val="solid"/>
+                      <a:round/>
+                      <a:headEnd type="none" w="med" len="med"/>
+                      <a:tailEnd type="none" w="med" len="med"/>
+                    </a:lnT>
+                    <a:lnB w="12700" cap="flat" cmpd="sng" algn="ctr">
+                      <a:solidFill>
+                        <a:schemeClr val="tx1"/>
+                      </a:solidFill>
+                      <a:prstDash val="solid"/>
+                      <a:round/>
+                      <a:headEnd type="none" w="med" len="med"/>
+                      <a:tailEnd type="none" w="med" len="med"/>
+                    </a:lnB>
+                  </a:tcPr>
+                </a:tc>
+                <a:extLst>
+                  <a:ext uri="{0D108BD9-81ED-4DB2-BD59-A6C34878D82A}">
+                    <a16:rowId xmlns:a16="http://schemas.microsoft.com/office/drawing/2014/main" val="10002"/>
+                  </a:ext>
+                </a:extLst>
+              </a:tr>
+            </a:tbl>
+          </a:graphicData>
+        </a:graphic>
+      </p:graphicFrame>
+      <p:sp>
+        <p:nvSpPr>
+          <p:cNvPr id="2" name="Rectangle 1"/>
+          <p:cNvSpPr/>
+          <p:nvPr/>
+        </p:nvSpPr>
+        <p:spPr>
+          <a:xfrm>
+            <a:off x="2019300" y="6248400"/>
+            <a:ext cx="8153400" cy="461665"/>
+          </a:xfrm>
+          <a:prstGeom prst="rect">
+            <a:avLst/>
+          </a:prstGeom>
+        </p:spPr>
+        <p:txBody>
+          <a:bodyPr wrap="square">
+            <a:spAutoFit/>
+          </a:bodyPr>
+          <a:lstStyle/>
+          <a:p>
+            <a:pPr algn="ctr"/>
+            <a:r>
+              <a:rPr lang="en-IE" sz="2400" dirty="0">
+                <a:hlinkClick r:id="rId3"/>
+              </a:rPr>
+              <a:t>http://en.wikipedia.org/wiki/List_of_Unicode_characters</a:t>
+            </a:r>
+            <a:endParaRPr lang="en-IE" sz="2400" dirty="0"/>
+          </a:p>
+        </p:txBody>
+      </p:sp>
+    </p:spTree>
+    <p:extLst>
+      <p:ext uri="{BB962C8B-B14F-4D97-AF65-F5344CB8AC3E}">
+        <p14:creationId xmlns:p14="http://schemas.microsoft.com/office/powerpoint/2010/main" val="327474517"/>
+      </p:ext>
+    </p:extLst>
+  </p:cSld>
+  <p:clrMapOvr>
+    <a:masterClrMapping/>
+  </p:clrMapOvr>
+  <p:transition/>
+</p:sld>
+</file>
+
+<file path=ppt/slides/slide28.xml><?xml version="1.0" encoding="utf-8"?>
+<p:sld xmlns:a="http://schemas.openxmlformats.org/drawingml/2006/main" xmlns:r="http://schemas.openxmlformats.org/officeDocument/2006/relationships" xmlns:p="http://schemas.openxmlformats.org/presentationml/2006/main">
+  <p:cSld>
+    <p:spTree>
+      <p:nvGrpSpPr>
+        <p:cNvPr id="1" name="">
+          <a:extLst>
+            <a:ext uri="{FF2B5EF4-FFF2-40B4-BE49-F238E27FC236}">
               <a16:creationId xmlns:a16="http://schemas.microsoft.com/office/drawing/2014/main" id="{04F94D03-749A-69EA-2B38-FAE12360B587}"/>
             </a:ext>
           </a:extLst>
@@ -17663,7 +19407,7 @@
 </p:sld>
 </file>
 
-<file path=ppt/slides/slide27.xml><?xml version="1.0" encoding="utf-8"?>
+<file path=ppt/slides/slide29.xml><?xml version="1.0" encoding="utf-8"?>
 <p:sld xmlns:a="http://schemas.openxmlformats.org/drawingml/2006/main" xmlns:r="http://schemas.openxmlformats.org/officeDocument/2006/relationships" xmlns:p="http://schemas.openxmlformats.org/presentationml/2006/main">
   <p:cSld>
     <p:spTree>
@@ -18603,7 +20347,354 @@
 </p:sld>
 </file>
 
-<file path=ppt/slides/slide28.xml><?xml version="1.0" encoding="utf-8"?>
+<file path=ppt/slides/slide3.xml><?xml version="1.0" encoding="utf-8"?>
+<p:sld xmlns:a="http://schemas.openxmlformats.org/drawingml/2006/main" xmlns:r="http://schemas.openxmlformats.org/officeDocument/2006/relationships" xmlns:p="http://schemas.openxmlformats.org/presentationml/2006/main">
+  <p:cSld>
+    <p:spTree>
+      <p:nvGrpSpPr>
+        <p:cNvPr id="1" name=""/>
+        <p:cNvGrpSpPr/>
+        <p:nvPr/>
+      </p:nvGrpSpPr>
+      <p:grpSpPr>
+        <a:xfrm>
+          <a:off x="0" y="0"/>
+          <a:ext cx="0" cy="0"/>
+          <a:chOff x="0" y="0"/>
+          <a:chExt cx="0" cy="0"/>
+        </a:xfrm>
+      </p:grpSpPr>
+      <p:sp>
+        <p:nvSpPr>
+          <p:cNvPr id="2" name="Title 1"/>
+          <p:cNvSpPr>
+            <a:spLocks noGrp="1"/>
+          </p:cNvSpPr>
+          <p:nvPr>
+            <p:ph type="title"/>
+          </p:nvPr>
+        </p:nvSpPr>
+        <p:spPr/>
+        <p:txBody>
+          <a:bodyPr/>
+          <a:lstStyle/>
+          <a:p>
+            <a:r>
+              <a:rPr lang="en-IE" dirty="0"/>
+              <a:t>Variables</a:t>
+            </a:r>
+          </a:p>
+        </p:txBody>
+      </p:sp>
+      <p:sp>
+        <p:nvSpPr>
+          <p:cNvPr id="3" name="Content Placeholder 2"/>
+          <p:cNvSpPr>
+            <a:spLocks noGrp="1"/>
+          </p:cNvSpPr>
+          <p:nvPr>
+            <p:ph idx="1"/>
+          </p:nvPr>
+        </p:nvSpPr>
+        <p:spPr/>
+        <p:txBody>
+          <a:bodyPr>
+            <a:normAutofit/>
+          </a:bodyPr>
+          <a:lstStyle/>
+          <a:p>
+            <a:pPr marL="0" indent="0">
+              <a:buNone/>
+            </a:pPr>
+            <a:r>
+              <a:rPr lang="en-IE" dirty="0"/>
+              <a:t>In Programming, variables:</a:t>
+            </a:r>
+          </a:p>
+          <a:p>
+            <a:pPr marL="0" indent="0">
+              <a:buNone/>
+            </a:pPr>
+            <a:endParaRPr lang="en-IE" dirty="0"/>
+          </a:p>
+          <a:p>
+            <a:r>
+              <a:rPr lang="en-IE" dirty="0"/>
+              <a:t>are created (defined) in your programs.</a:t>
+            </a:r>
+          </a:p>
+          <a:p>
+            <a:r>
+              <a:rPr lang="en-IE" dirty="0"/>
+              <a:t>are used to store data (whose value can change over time).</a:t>
+            </a:r>
+          </a:p>
+          <a:p>
+            <a:r>
+              <a:rPr lang="en-IE" dirty="0"/>
+              <a:t>have a data type.</a:t>
+            </a:r>
+          </a:p>
+          <a:p>
+            <a:r>
+              <a:rPr lang="en-IE" dirty="0"/>
+              <a:t>have a name.</a:t>
+            </a:r>
+          </a:p>
+          <a:p>
+            <a:r>
+              <a:rPr lang="en-IE" dirty="0"/>
+              <a:t>are a VERY important programming concept.</a:t>
+            </a:r>
+          </a:p>
+        </p:txBody>
+      </p:sp>
+    </p:spTree>
+    <p:custDataLst>
+      <p:tags r:id="rId1"/>
+    </p:custDataLst>
+    <p:extLst>
+      <p:ext uri="{BB962C8B-B14F-4D97-AF65-F5344CB8AC3E}">
+        <p14:creationId xmlns:p14="http://schemas.microsoft.com/office/powerpoint/2010/main" val="2016246218"/>
+      </p:ext>
+    </p:extLst>
+  </p:cSld>
+  <p:clrMapOvr>
+    <a:masterClrMapping/>
+  </p:clrMapOvr>
+  <p:timing>
+    <p:tnLst>
+      <p:par>
+        <p:cTn id="1" dur="indefinite" restart="never" nodeType="tmRoot">
+          <p:childTnLst>
+            <p:seq concurrent="1" nextAc="seek">
+              <p:cTn id="2" dur="indefinite" nodeType="mainSeq">
+                <p:childTnLst>
+                  <p:par>
+                    <p:cTn id="3" fill="hold">
+                      <p:stCondLst>
+                        <p:cond delay="indefinite"/>
+                      </p:stCondLst>
+                      <p:childTnLst>
+                        <p:par>
+                          <p:cTn id="4" fill="hold">
+                            <p:stCondLst>
+                              <p:cond delay="0"/>
+                            </p:stCondLst>
+                            <p:childTnLst>
+                              <p:par>
+                                <p:cTn id="5" presetID="1" presetClass="entr" presetSubtype="0" fill="hold" grpId="0" nodeType="clickEffect">
+                                  <p:stCondLst>
+                                    <p:cond delay="0"/>
+                                  </p:stCondLst>
+                                  <p:childTnLst>
+                                    <p:set>
+                                      <p:cBhvr>
+                                        <p:cTn id="6" dur="1" fill="hold">
+                                          <p:stCondLst>
+                                            <p:cond delay="0"/>
+                                          </p:stCondLst>
+                                        </p:cTn>
+                                        <p:tgtEl>
+                                          <p:spTgt spid="3">
+                                            <p:txEl>
+                                              <p:pRg st="3" end="3"/>
+                                            </p:txEl>
+                                          </p:spTgt>
+                                        </p:tgtEl>
+                                        <p:attrNameLst>
+                                          <p:attrName>style.visibility</p:attrName>
+                                        </p:attrNameLst>
+                                      </p:cBhvr>
+                                      <p:to>
+                                        <p:strVal val="visible"/>
+                                      </p:to>
+                                    </p:set>
+                                  </p:childTnLst>
+                                </p:cTn>
+                              </p:par>
+                            </p:childTnLst>
+                          </p:cTn>
+                        </p:par>
+                      </p:childTnLst>
+                    </p:cTn>
+                  </p:par>
+                  <p:par>
+                    <p:cTn id="7" fill="hold">
+                      <p:stCondLst>
+                        <p:cond delay="indefinite"/>
+                      </p:stCondLst>
+                      <p:childTnLst>
+                        <p:par>
+                          <p:cTn id="8" fill="hold">
+                            <p:stCondLst>
+                              <p:cond delay="0"/>
+                            </p:stCondLst>
+                            <p:childTnLst>
+                              <p:par>
+                                <p:cTn id="9" presetID="1" presetClass="entr" presetSubtype="0" fill="hold" grpId="0" nodeType="clickEffect">
+                                  <p:stCondLst>
+                                    <p:cond delay="0"/>
+                                  </p:stCondLst>
+                                  <p:childTnLst>
+                                    <p:set>
+                                      <p:cBhvr>
+                                        <p:cTn id="10" dur="1" fill="hold">
+                                          <p:stCondLst>
+                                            <p:cond delay="0"/>
+                                          </p:stCondLst>
+                                        </p:cTn>
+                                        <p:tgtEl>
+                                          <p:spTgt spid="3">
+                                            <p:txEl>
+                                              <p:pRg st="4" end="4"/>
+                                            </p:txEl>
+                                          </p:spTgt>
+                                        </p:tgtEl>
+                                        <p:attrNameLst>
+                                          <p:attrName>style.visibility</p:attrName>
+                                        </p:attrNameLst>
+                                      </p:cBhvr>
+                                      <p:to>
+                                        <p:strVal val="visible"/>
+                                      </p:to>
+                                    </p:set>
+                                  </p:childTnLst>
+                                </p:cTn>
+                              </p:par>
+                            </p:childTnLst>
+                          </p:cTn>
+                        </p:par>
+                      </p:childTnLst>
+                    </p:cTn>
+                  </p:par>
+                  <p:par>
+                    <p:cTn id="11" fill="hold">
+                      <p:stCondLst>
+                        <p:cond delay="indefinite"/>
+                      </p:stCondLst>
+                      <p:childTnLst>
+                        <p:par>
+                          <p:cTn id="12" fill="hold">
+                            <p:stCondLst>
+                              <p:cond delay="0"/>
+                            </p:stCondLst>
+                            <p:childTnLst>
+                              <p:par>
+                                <p:cTn id="13" presetID="1" presetClass="entr" presetSubtype="0" fill="hold" grpId="0" nodeType="clickEffect">
+                                  <p:stCondLst>
+                                    <p:cond delay="0"/>
+                                  </p:stCondLst>
+                                  <p:childTnLst>
+                                    <p:set>
+                                      <p:cBhvr>
+                                        <p:cTn id="14" dur="1" fill="hold">
+                                          <p:stCondLst>
+                                            <p:cond delay="0"/>
+                                          </p:stCondLst>
+                                        </p:cTn>
+                                        <p:tgtEl>
+                                          <p:spTgt spid="3">
+                                            <p:txEl>
+                                              <p:pRg st="5" end="5"/>
+                                            </p:txEl>
+                                          </p:spTgt>
+                                        </p:tgtEl>
+                                        <p:attrNameLst>
+                                          <p:attrName>style.visibility</p:attrName>
+                                        </p:attrNameLst>
+                                      </p:cBhvr>
+                                      <p:to>
+                                        <p:strVal val="visible"/>
+                                      </p:to>
+                                    </p:set>
+                                  </p:childTnLst>
+                                </p:cTn>
+                              </p:par>
+                            </p:childTnLst>
+                          </p:cTn>
+                        </p:par>
+                      </p:childTnLst>
+                    </p:cTn>
+                  </p:par>
+                  <p:par>
+                    <p:cTn id="15" fill="hold">
+                      <p:stCondLst>
+                        <p:cond delay="indefinite"/>
+                      </p:stCondLst>
+                      <p:childTnLst>
+                        <p:par>
+                          <p:cTn id="16" fill="hold">
+                            <p:stCondLst>
+                              <p:cond delay="0"/>
+                            </p:stCondLst>
+                            <p:childTnLst>
+                              <p:par>
+                                <p:cTn id="17" presetID="1" presetClass="entr" presetSubtype="0" fill="hold" grpId="0" nodeType="clickEffect">
+                                  <p:stCondLst>
+                                    <p:cond delay="0"/>
+                                  </p:stCondLst>
+                                  <p:childTnLst>
+                                    <p:set>
+                                      <p:cBhvr>
+                                        <p:cTn id="18" dur="1" fill="hold">
+                                          <p:stCondLst>
+                                            <p:cond delay="0"/>
+                                          </p:stCondLst>
+                                        </p:cTn>
+                                        <p:tgtEl>
+                                          <p:spTgt spid="3">
+                                            <p:txEl>
+                                              <p:pRg st="6" end="6"/>
+                                            </p:txEl>
+                                          </p:spTgt>
+                                        </p:tgtEl>
+                                        <p:attrNameLst>
+                                          <p:attrName>style.visibility</p:attrName>
+                                        </p:attrNameLst>
+                                      </p:cBhvr>
+                                      <p:to>
+                                        <p:strVal val="visible"/>
+                                      </p:to>
+                                    </p:set>
+                                  </p:childTnLst>
+                                </p:cTn>
+                              </p:par>
+                            </p:childTnLst>
+                          </p:cTn>
+                        </p:par>
+                      </p:childTnLst>
+                    </p:cTn>
+                  </p:par>
+                </p:childTnLst>
+              </p:cTn>
+              <p:prevCondLst>
+                <p:cond evt="onPrev" delay="0">
+                  <p:tgtEl>
+                    <p:sldTgt/>
+                  </p:tgtEl>
+                </p:cond>
+              </p:prevCondLst>
+              <p:nextCondLst>
+                <p:cond evt="onNext" delay="0">
+                  <p:tgtEl>
+                    <p:sldTgt/>
+                  </p:tgtEl>
+                </p:cond>
+              </p:nextCondLst>
+            </p:seq>
+          </p:childTnLst>
+        </p:cTn>
+      </p:par>
+    </p:tnLst>
+    <p:bldLst>
+      <p:bldP spid="3" grpId="0" uiExpand="1" build="p"/>
+    </p:bldLst>
+  </p:timing>
+</p:sld>
+</file>
+
+<file path=ppt/slides/slide30.xml><?xml version="1.0" encoding="utf-8"?>
 <p:sld xmlns:a="http://schemas.openxmlformats.org/drawingml/2006/main" xmlns:r="http://schemas.openxmlformats.org/officeDocument/2006/relationships" xmlns:p="http://schemas.openxmlformats.org/presentationml/2006/main">
   <p:cSld>
     <p:spTree>
@@ -19245,7 +21336,7 @@
             <a:pPr algn="ctr"/>
             <a:r>
               <a:rPr lang="en-US" dirty="0"/>
-              <a:t>Either x or y or bot are non-integers</a:t>
+              <a:t>Either x or y or both are non-integers</a:t>
             </a:r>
           </a:p>
         </p:txBody>
@@ -20994,7 +23085,7 @@
 </p:sld>
 </file>
 
-<file path=ppt/slides/slide29.xml><?xml version="1.0" encoding="utf-8"?>
+<file path=ppt/slides/slide31.xml><?xml version="1.0" encoding="utf-8"?>
 <p:sld xmlns:a="http://schemas.openxmlformats.org/drawingml/2006/main" xmlns:r="http://schemas.openxmlformats.org/officeDocument/2006/relationships" xmlns:p="http://schemas.openxmlformats.org/presentationml/2006/main">
   <p:cSld>
     <p:spTree>
@@ -21079,353 +23170,6 @@
   <p:clrMapOvr>
     <a:masterClrMapping/>
   </p:clrMapOvr>
-</p:sld>
-</file>
-
-<file path=ppt/slides/slide3.xml><?xml version="1.0" encoding="utf-8"?>
-<p:sld xmlns:a="http://schemas.openxmlformats.org/drawingml/2006/main" xmlns:r="http://schemas.openxmlformats.org/officeDocument/2006/relationships" xmlns:p="http://schemas.openxmlformats.org/presentationml/2006/main">
-  <p:cSld>
-    <p:spTree>
-      <p:nvGrpSpPr>
-        <p:cNvPr id="1" name=""/>
-        <p:cNvGrpSpPr/>
-        <p:nvPr/>
-      </p:nvGrpSpPr>
-      <p:grpSpPr>
-        <a:xfrm>
-          <a:off x="0" y="0"/>
-          <a:ext cx="0" cy="0"/>
-          <a:chOff x="0" y="0"/>
-          <a:chExt cx="0" cy="0"/>
-        </a:xfrm>
-      </p:grpSpPr>
-      <p:sp>
-        <p:nvSpPr>
-          <p:cNvPr id="2" name="Title 1"/>
-          <p:cNvSpPr>
-            <a:spLocks noGrp="1"/>
-          </p:cNvSpPr>
-          <p:nvPr>
-            <p:ph type="title"/>
-          </p:nvPr>
-        </p:nvSpPr>
-        <p:spPr/>
-        <p:txBody>
-          <a:bodyPr/>
-          <a:lstStyle/>
-          <a:p>
-            <a:r>
-              <a:rPr lang="en-IE" dirty="0"/>
-              <a:t>Variables</a:t>
-            </a:r>
-          </a:p>
-        </p:txBody>
-      </p:sp>
-      <p:sp>
-        <p:nvSpPr>
-          <p:cNvPr id="3" name="Content Placeholder 2"/>
-          <p:cNvSpPr>
-            <a:spLocks noGrp="1"/>
-          </p:cNvSpPr>
-          <p:nvPr>
-            <p:ph idx="1"/>
-          </p:nvPr>
-        </p:nvSpPr>
-        <p:spPr/>
-        <p:txBody>
-          <a:bodyPr>
-            <a:normAutofit/>
-          </a:bodyPr>
-          <a:lstStyle/>
-          <a:p>
-            <a:pPr marL="0" indent="0">
-              <a:buNone/>
-            </a:pPr>
-            <a:r>
-              <a:rPr lang="en-IE" dirty="0"/>
-              <a:t>In Programming, variables:</a:t>
-            </a:r>
-          </a:p>
-          <a:p>
-            <a:pPr marL="0" indent="0">
-              <a:buNone/>
-            </a:pPr>
-            <a:endParaRPr lang="en-IE" dirty="0"/>
-          </a:p>
-          <a:p>
-            <a:r>
-              <a:rPr lang="en-IE" dirty="0"/>
-              <a:t>are created (defined) in your programs.</a:t>
-            </a:r>
-          </a:p>
-          <a:p>
-            <a:r>
-              <a:rPr lang="en-IE" dirty="0"/>
-              <a:t>are used to store data (whose value can change over time).</a:t>
-            </a:r>
-          </a:p>
-          <a:p>
-            <a:r>
-              <a:rPr lang="en-IE" dirty="0"/>
-              <a:t>have a data type.</a:t>
-            </a:r>
-          </a:p>
-          <a:p>
-            <a:r>
-              <a:rPr lang="en-IE" dirty="0"/>
-              <a:t>have a name.</a:t>
-            </a:r>
-          </a:p>
-          <a:p>
-            <a:r>
-              <a:rPr lang="en-IE" dirty="0"/>
-              <a:t>are a VERY important programming concept.</a:t>
-            </a:r>
-          </a:p>
-        </p:txBody>
-      </p:sp>
-    </p:spTree>
-    <p:custDataLst>
-      <p:tags r:id="rId1"/>
-    </p:custDataLst>
-    <p:extLst>
-      <p:ext uri="{BB962C8B-B14F-4D97-AF65-F5344CB8AC3E}">
-        <p14:creationId xmlns:p14="http://schemas.microsoft.com/office/powerpoint/2010/main" val="2016246218"/>
-      </p:ext>
-    </p:extLst>
-  </p:cSld>
-  <p:clrMapOvr>
-    <a:masterClrMapping/>
-  </p:clrMapOvr>
-  <p:timing>
-    <p:tnLst>
-      <p:par>
-        <p:cTn id="1" dur="indefinite" restart="never" nodeType="tmRoot">
-          <p:childTnLst>
-            <p:seq concurrent="1" nextAc="seek">
-              <p:cTn id="2" dur="indefinite" nodeType="mainSeq">
-                <p:childTnLst>
-                  <p:par>
-                    <p:cTn id="3" fill="hold">
-                      <p:stCondLst>
-                        <p:cond delay="indefinite"/>
-                      </p:stCondLst>
-                      <p:childTnLst>
-                        <p:par>
-                          <p:cTn id="4" fill="hold">
-                            <p:stCondLst>
-                              <p:cond delay="0"/>
-                            </p:stCondLst>
-                            <p:childTnLst>
-                              <p:par>
-                                <p:cTn id="5" presetID="1" presetClass="entr" presetSubtype="0" fill="hold" grpId="0" nodeType="clickEffect">
-                                  <p:stCondLst>
-                                    <p:cond delay="0"/>
-                                  </p:stCondLst>
-                                  <p:childTnLst>
-                                    <p:set>
-                                      <p:cBhvr>
-                                        <p:cTn id="6" dur="1" fill="hold">
-                                          <p:stCondLst>
-                                            <p:cond delay="0"/>
-                                          </p:stCondLst>
-                                        </p:cTn>
-                                        <p:tgtEl>
-                                          <p:spTgt spid="3">
-                                            <p:txEl>
-                                              <p:pRg st="3" end="3"/>
-                                            </p:txEl>
-                                          </p:spTgt>
-                                        </p:tgtEl>
-                                        <p:attrNameLst>
-                                          <p:attrName>style.visibility</p:attrName>
-                                        </p:attrNameLst>
-                                      </p:cBhvr>
-                                      <p:to>
-                                        <p:strVal val="visible"/>
-                                      </p:to>
-                                    </p:set>
-                                  </p:childTnLst>
-                                </p:cTn>
-                              </p:par>
-                            </p:childTnLst>
-                          </p:cTn>
-                        </p:par>
-                      </p:childTnLst>
-                    </p:cTn>
-                  </p:par>
-                  <p:par>
-                    <p:cTn id="7" fill="hold">
-                      <p:stCondLst>
-                        <p:cond delay="indefinite"/>
-                      </p:stCondLst>
-                      <p:childTnLst>
-                        <p:par>
-                          <p:cTn id="8" fill="hold">
-                            <p:stCondLst>
-                              <p:cond delay="0"/>
-                            </p:stCondLst>
-                            <p:childTnLst>
-                              <p:par>
-                                <p:cTn id="9" presetID="1" presetClass="entr" presetSubtype="0" fill="hold" grpId="0" nodeType="clickEffect">
-                                  <p:stCondLst>
-                                    <p:cond delay="0"/>
-                                  </p:stCondLst>
-                                  <p:childTnLst>
-                                    <p:set>
-                                      <p:cBhvr>
-                                        <p:cTn id="10" dur="1" fill="hold">
-                                          <p:stCondLst>
-                                            <p:cond delay="0"/>
-                                          </p:stCondLst>
-                                        </p:cTn>
-                                        <p:tgtEl>
-                                          <p:spTgt spid="3">
-                                            <p:txEl>
-                                              <p:pRg st="4" end="4"/>
-                                            </p:txEl>
-                                          </p:spTgt>
-                                        </p:tgtEl>
-                                        <p:attrNameLst>
-                                          <p:attrName>style.visibility</p:attrName>
-                                        </p:attrNameLst>
-                                      </p:cBhvr>
-                                      <p:to>
-                                        <p:strVal val="visible"/>
-                                      </p:to>
-                                    </p:set>
-                                  </p:childTnLst>
-                                </p:cTn>
-                              </p:par>
-                            </p:childTnLst>
-                          </p:cTn>
-                        </p:par>
-                      </p:childTnLst>
-                    </p:cTn>
-                  </p:par>
-                  <p:par>
-                    <p:cTn id="11" fill="hold">
-                      <p:stCondLst>
-                        <p:cond delay="indefinite"/>
-                      </p:stCondLst>
-                      <p:childTnLst>
-                        <p:par>
-                          <p:cTn id="12" fill="hold">
-                            <p:stCondLst>
-                              <p:cond delay="0"/>
-                            </p:stCondLst>
-                            <p:childTnLst>
-                              <p:par>
-                                <p:cTn id="13" presetID="1" presetClass="entr" presetSubtype="0" fill="hold" grpId="0" nodeType="clickEffect">
-                                  <p:stCondLst>
-                                    <p:cond delay="0"/>
-                                  </p:stCondLst>
-                                  <p:childTnLst>
-                                    <p:set>
-                                      <p:cBhvr>
-                                        <p:cTn id="14" dur="1" fill="hold">
-                                          <p:stCondLst>
-                                            <p:cond delay="0"/>
-                                          </p:stCondLst>
-                                        </p:cTn>
-                                        <p:tgtEl>
-                                          <p:spTgt spid="3">
-                                            <p:txEl>
-                                              <p:pRg st="5" end="5"/>
-                                            </p:txEl>
-                                          </p:spTgt>
-                                        </p:tgtEl>
-                                        <p:attrNameLst>
-                                          <p:attrName>style.visibility</p:attrName>
-                                        </p:attrNameLst>
-                                      </p:cBhvr>
-                                      <p:to>
-                                        <p:strVal val="visible"/>
-                                      </p:to>
-                                    </p:set>
-                                  </p:childTnLst>
-                                </p:cTn>
-                              </p:par>
-                            </p:childTnLst>
-                          </p:cTn>
-                        </p:par>
-                      </p:childTnLst>
-                    </p:cTn>
-                  </p:par>
-                  <p:par>
-                    <p:cTn id="15" fill="hold">
-                      <p:stCondLst>
-                        <p:cond delay="indefinite"/>
-                      </p:stCondLst>
-                      <p:childTnLst>
-                        <p:par>
-                          <p:cTn id="16" fill="hold">
-                            <p:stCondLst>
-                              <p:cond delay="0"/>
-                            </p:stCondLst>
-                            <p:childTnLst>
-                              <p:par>
-                                <p:cTn id="17" presetID="1" presetClass="entr" presetSubtype="0" fill="hold" grpId="0" nodeType="clickEffect">
-                                  <p:stCondLst>
-                                    <p:cond delay="0"/>
-                                  </p:stCondLst>
-                                  <p:childTnLst>
-                                    <p:set>
-                                      <p:cBhvr>
-                                        <p:cTn id="18" dur="1" fill="hold">
-                                          <p:stCondLst>
-                                            <p:cond delay="0"/>
-                                          </p:stCondLst>
-                                        </p:cTn>
-                                        <p:tgtEl>
-                                          <p:spTgt spid="3">
-                                            <p:txEl>
-                                              <p:pRg st="6" end="6"/>
-                                            </p:txEl>
-                                          </p:spTgt>
-                                        </p:tgtEl>
-                                        <p:attrNameLst>
-                                          <p:attrName>style.visibility</p:attrName>
-                                        </p:attrNameLst>
-                                      </p:cBhvr>
-                                      <p:to>
-                                        <p:strVal val="visible"/>
-                                      </p:to>
-                                    </p:set>
-                                  </p:childTnLst>
-                                </p:cTn>
-                              </p:par>
-                            </p:childTnLst>
-                          </p:cTn>
-                        </p:par>
-                      </p:childTnLst>
-                    </p:cTn>
-                  </p:par>
-                </p:childTnLst>
-              </p:cTn>
-              <p:prevCondLst>
-                <p:cond evt="onPrev" delay="0">
-                  <p:tgtEl>
-                    <p:sldTgt/>
-                  </p:tgtEl>
-                </p:cond>
-              </p:prevCondLst>
-              <p:nextCondLst>
-                <p:cond evt="onNext" delay="0">
-                  <p:tgtEl>
-                    <p:sldTgt/>
-                  </p:tgtEl>
-                </p:cond>
-              </p:nextCondLst>
-            </p:seq>
-          </p:childTnLst>
-        </p:cTn>
-      </p:par>
-    </p:tnLst>
-    <p:bldLst>
-      <p:bldP spid="3" grpId="0" uiExpand="1" build="p"/>
-    </p:bldLst>
-  </p:timing>
 </p:sld>
 </file>
 

</xml_diff>